<commit_message>
Update introduction course slides
</commit_message>
<xml_diff>
--- a/course slides/ppt/Lec 1_ Introduction to course.pptx
+++ b/course slides/ppt/Lec 1_ Introduction to course.pptx
@@ -4,20 +4,19 @@
   <p:sldMasterIdLst>
     <p:sldMasterId id="2147483648" r:id="rId1"/>
   </p:sldMasterIdLst>
+  <p:notesMasterIdLst>
+    <p:notesMasterId r:id="rId9"/>
+  </p:notesMasterIdLst>
   <p:sldIdLst>
     <p:sldId id="256" r:id="rId2"/>
     <p:sldId id="257" r:id="rId3"/>
     <p:sldId id="258" r:id="rId4"/>
     <p:sldId id="259" r:id="rId5"/>
-    <p:sldId id="260" r:id="rId6"/>
-    <p:sldId id="261" r:id="rId7"/>
-    <p:sldId id="262" r:id="rId8"/>
-    <p:sldId id="263" r:id="rId9"/>
+    <p:sldId id="261" r:id="rId6"/>
+    <p:sldId id="262" r:id="rId7"/>
+    <p:sldId id="263" r:id="rId8"/>
   </p:sldIdLst>
-  <p:notesMasterIdLst>
-    <p:notesMasterId r:id="rId10"/>
-  </p:notesMasterIdLst>
-  <p:sldSz cx="9144000" cy="5143500"/>
+  <p:sldSz cx="9144000" cy="5143500" type="screen16x9"/>
   <p:notesSz cx="5143500" cy="9144000"/>
   <p:defaultTextStyle>
     <a:lvl1pPr marL="0" algn="l" defTabSz="914400" rtl="0" eaLnBrk="1" latinLnBrk="0" hangingPunct="1">
@@ -111,6 +110,11 @@
       </a:defRPr>
     </a:lvl9pPr>
   </p:defaultTextStyle>
+  <p:extLst>
+    <p:ext uri="{EFAFB233-063F-42B5-8137-9DF3F51BA10A}">
+      <p15:sldGuideLst xmlns:p15="http://schemas.microsoft.com/office/powerpoint/2012/main"/>
+    </p:ext>
+  </p:extLst>
 </p:presentation>
 </file>
 
@@ -136,234 +140,10 @@
           <a:chExt cx="0" cy="0"/>
         </a:xfrm>
       </p:grpSpPr>
-      <p:sp>
-        <p:nvSpPr>
-          <p:cNvPr id="2" name="Header Placeholder 1"/>
-          <p:cNvSpPr>
-            <a:spLocks noGrp="1"/>
-          </p:cNvSpPr>
-          <p:nvPr>
-            <p:ph type="hdr" sz="quarter"/>
-          </p:nvPr>
-        </p:nvSpPr>
-        <p:spPr>
-          <a:xfrm>
-            <a:off x="0" y="0"/>
-            <a:ext cx="2971800" cy="458788"/>
-          </a:xfrm>
-          <a:prstGeom prst="rect">
-            <a:avLst/>
-          </a:prstGeom>
-        </p:spPr>
-        <p:txBody>
-          <a:bodyPr vert="horz" lIns="91440" tIns="45720" rIns="91440" bIns="45720" rtlCol="0"/>
-          <a:lstStyle>
-            <a:lvl1pPr algn="l">
-              <a:defRPr sz="1200"/>
-            </a:lvl1pPr>
-          </a:lstStyle>
-          <a:p>
-            <a:endParaRPr lang="en-US"/>
-          </a:p>
-        </p:txBody>
-      </p:sp>
-      <p:sp>
-        <p:nvSpPr>
-          <p:cNvPr id="3" name="Date Placeholder 2"/>
-          <p:cNvSpPr>
-            <a:spLocks noGrp="1"/>
-          </p:cNvSpPr>
-          <p:nvPr>
-            <p:ph type="dt" idx="1"/>
-          </p:nvPr>
-        </p:nvSpPr>
-        <p:spPr>
-          <a:xfrm>
-            <a:off x="3884613" y="0"/>
-            <a:ext cx="2971800" cy="458788"/>
-          </a:xfrm>
-          <a:prstGeom prst="rect">
-            <a:avLst/>
-          </a:prstGeom>
-        </p:spPr>
-        <p:txBody>
-          <a:bodyPr vert="horz" lIns="91440" tIns="45720" rIns="91440" bIns="45720" rtlCol="0"/>
-          <a:lstStyle>
-            <a:lvl1pPr algn="r">
-              <a:defRPr sz="1200"/>
-            </a:lvl1pPr>
-          </a:lstStyle>
-          <a:p>
-            <a:fld id="{5282F153-3F37-0F45-9E97-73ACFA13230C}" type="datetimeFigureOut">
-              <a:rPr lang="en-US"/>
-              <a:t>7/23/19</a:t>
-            </a:fld>
-            <a:endParaRPr lang="en-US"/>
-          </a:p>
-        </p:txBody>
-      </p:sp>
-      <p:sp>
-        <p:nvSpPr>
-          <p:cNvPr id="4" name="Slide Image Placeholder 3"/>
-          <p:cNvSpPr>
-            <a:spLocks noGrp="1" noRot="1" noChangeAspect="1"/>
-          </p:cNvSpPr>
-          <p:nvPr>
-            <p:ph type="sldImg" idx="2"/>
-          </p:nvPr>
-        </p:nvSpPr>
-        <p:spPr>
-          <a:xfrm>
-            <a:off x="685800" y="1143000"/>
-            <a:ext cx="5486400" cy="3086100"/>
-          </a:xfrm>
-          <a:prstGeom prst="rect">
-            <a:avLst/>
-          </a:prstGeom>
-          <a:noFill/>
-          <a:ln w="12700">
-            <a:solidFill>
-              <a:prstClr val="black"/>
-            </a:solidFill>
-          </a:ln>
-        </p:spPr>
-        <p:txBody>
-          <a:bodyPr vert="horz" lIns="91440" tIns="45720" rIns="91440" bIns="45720" rtlCol="0" anchor="ctr"/>
-          <a:lstStyle/>
-          <a:p>
-            <a:endParaRPr lang="en-US"/>
-          </a:p>
-        </p:txBody>
-      </p:sp>
-      <p:sp>
-        <p:nvSpPr>
-          <p:cNvPr id="5" name="Notes Placeholder 4"/>
-          <p:cNvSpPr>
-            <a:spLocks noGrp="1"/>
-          </p:cNvSpPr>
-          <p:nvPr>
-            <p:ph type="body" sz="quarter" idx="3"/>
-          </p:nvPr>
-        </p:nvSpPr>
-        <p:spPr>
-          <a:xfrm>
-            <a:off x="685800" y="4400550"/>
-            <a:ext cx="5486400" cy="3600450"/>
-          </a:xfrm>
-          <a:prstGeom prst="rect">
-            <a:avLst/>
-          </a:prstGeom>
-        </p:spPr>
-        <p:txBody>
-          <a:bodyPr vert="horz" lIns="91440" tIns="45720" rIns="91440" bIns="45720" rtlCol="0"/>
-          <a:lstStyle/>
-          <a:p>
-            <a:pPr lvl="0"/>
-            <a:r>
-              <a:rPr lang="en-US"/>
-              <a:t>Click to edit Master text styles</a:t>
-            </a:r>
-          </a:p>
-          <a:p>
-            <a:pPr lvl="1"/>
-            <a:r>
-              <a:rPr lang="en-US"/>
-              <a:t>Second level</a:t>
-            </a:r>
-          </a:p>
-          <a:p>
-            <a:pPr lvl="2"/>
-            <a:r>
-              <a:rPr lang="en-US"/>
-              <a:t>Third level</a:t>
-            </a:r>
-          </a:p>
-          <a:p>
-            <a:pPr lvl="3"/>
-            <a:r>
-              <a:rPr lang="en-US"/>
-              <a:t>Fourth level</a:t>
-            </a:r>
-          </a:p>
-          <a:p>
-            <a:pPr lvl="4"/>
-            <a:r>
-              <a:rPr lang="en-US"/>
-              <a:t>Fifth level</a:t>
-            </a:r>
-          </a:p>
-        </p:txBody>
-      </p:sp>
-      <p:sp>
-        <p:nvSpPr>
-          <p:cNvPr id="6" name="Footer Placeholder 5"/>
-          <p:cNvSpPr>
-            <a:spLocks noGrp="1"/>
-          </p:cNvSpPr>
-          <p:nvPr>
-            <p:ph type="ftr" sz="quarter" idx="4"/>
-          </p:nvPr>
-        </p:nvSpPr>
-        <p:spPr>
-          <a:xfrm>
-            <a:off x="0" y="8685213"/>
-            <a:ext cx="2971800" cy="458787"/>
-          </a:xfrm>
-          <a:prstGeom prst="rect">
-            <a:avLst/>
-          </a:prstGeom>
-        </p:spPr>
-        <p:txBody>
-          <a:bodyPr vert="horz" lIns="91440" tIns="45720" rIns="91440" bIns="45720" rtlCol="0" anchor="b"/>
-          <a:lstStyle>
-            <a:lvl1pPr algn="l">
-              <a:defRPr sz="1200"/>
-            </a:lvl1pPr>
-          </a:lstStyle>
-          <a:p>
-            <a:endParaRPr lang="en-US"/>
-          </a:p>
-        </p:txBody>
-      </p:sp>
-      <p:sp>
-        <p:nvSpPr>
-          <p:cNvPr id="7" name="Slide Number Placeholder 6"/>
-          <p:cNvSpPr>
-            <a:spLocks noGrp="1"/>
-          </p:cNvSpPr>
-          <p:nvPr>
-            <p:ph type="sldNum" sz="quarter" idx="5"/>
-          </p:nvPr>
-        </p:nvSpPr>
-        <p:spPr>
-          <a:xfrm>
-            <a:off x="3884613" y="8685213"/>
-            <a:ext cx="2971800" cy="458787"/>
-          </a:xfrm>
-          <a:prstGeom prst="rect">
-            <a:avLst/>
-          </a:prstGeom>
-        </p:spPr>
-        <p:txBody>
-          <a:bodyPr vert="horz" lIns="91440" tIns="45720" rIns="91440" bIns="45720" rtlCol="0" anchor="b"/>
-          <a:lstStyle>
-            <a:lvl1pPr algn="r">
-              <a:defRPr sz="1200"/>
-            </a:lvl1pPr>
-          </a:lstStyle>
-          <a:p>
-            <a:fld id="{CE5E9CC1-C706-0F49-92D6-E571CC5EEA8F}" type="slidenum">
-              <a:rPr lang="en-US"/>
-              <a:t>‹#›</a:t>
-            </a:fld>
-            <a:endParaRPr lang="en-US"/>
-          </a:p>
-        </p:txBody>
-      </p:sp>
     </p:spTree>
     <p:extLst>
       <p:ext uri="{BB962C8B-B14F-4D97-AF65-F5344CB8AC3E}">
-        <p14:creationId xmlns:p14="http://schemas.microsoft.com/office/powerpoint/2010/main" val="1024086991"/>
+        <p14:creationId xmlns:p14="http://schemas.microsoft.com/office/powerpoint/2010/main" val="1698321524"/>
       </p:ext>
     </p:extLst>
   </p:cSld>
@@ -516,7 +296,6 @@
 3) get up and running using unity 
 4) get excited to take this course </a:t>
             </a:r>
-            <a:endParaRPr lang="en-US" dirty="0"/>
           </a:p>
         </p:txBody>
       </p:sp>
@@ -600,10 +379,6 @@
           <a:bodyPr/>
           <a:lstStyle/>
           <a:p>
-            <a:r>
-              <a:rPr lang="en-US" dirty="0"/>
-              <a:t/>
-            </a:r>
             <a:endParaRPr lang="en-US" dirty="0"/>
           </a:p>
         </p:txBody>
@@ -688,10 +463,6 @@
           <a:bodyPr/>
           <a:lstStyle/>
           <a:p>
-            <a:r>
-              <a:rPr lang="en-US" dirty="0"/>
-              <a:t/>
-            </a:r>
             <a:endParaRPr lang="en-US" dirty="0"/>
           </a:p>
         </p:txBody>
@@ -776,10 +547,6 @@
           <a:bodyPr/>
           <a:lstStyle/>
           <a:p>
-            <a:r>
-              <a:rPr lang="en-US" dirty="0"/>
-              <a:t/>
-            </a:r>
             <a:endParaRPr lang="en-US" dirty="0"/>
           </a:p>
         </p:txBody>
@@ -864,13 +631,6 @@
           <a:bodyPr/>
           <a:lstStyle/>
           <a:p>
-            <a:r>
-              <a:rPr lang="en-US" dirty="0"/>
-              <a:t>Use discord for:
-Knowledge sharing 
-Discussions (activities/project) 
-NOT for official communication (grades, issues, ..)</a:t>
-            </a:r>
             <a:endParaRPr lang="en-US" dirty="0"/>
           </a:p>
         </p:txBody>
@@ -955,10 +715,6 @@
           <a:bodyPr/>
           <a:lstStyle/>
           <a:p>
-            <a:r>
-              <a:rPr lang="en-US" dirty="0"/>
-              <a:t/>
-            </a:r>
             <a:endParaRPr lang="en-US" dirty="0"/>
           </a:p>
         </p:txBody>
@@ -1043,10 +799,6 @@
           <a:bodyPr/>
           <a:lstStyle/>
           <a:p>
-            <a:r>
-              <a:rPr lang="en-US" dirty="0"/>
-              <a:t/>
-            </a:r>
             <a:endParaRPr lang="en-US" dirty="0"/>
           </a:p>
         </p:txBody>
@@ -1069,94 +821,6 @@
             <a:fld id="{F7021451-1387-4CA6-816F-3879F97B5CBC}" type="slidenum">
               <a:rPr lang="en-US"/>
               <a:t>7</a:t>
-            </a:fld>
-            <a:endParaRPr lang="en-US"/>
-          </a:p>
-        </p:txBody>
-      </p:sp>
-    </p:spTree>
-    <p:extLst>
-      <p:ext uri="{BB962C8B-B14F-4D97-AF65-F5344CB8AC3E}">
-        <p14:creationId xmlns:p14="http://schemas.microsoft.com/office/powerpoint/2010/main" val="1024086991"/>
-      </p:ext>
-    </p:extLst>
-  </p:cSld>
-  <p:clrMapOvr>
-    <a:masterClrMapping/>
-  </p:clrMapOvr>
-</p:notes>
-</file>
-
-<file path=ppt/notesSlides/notesSlide8.xml><?xml version="1.0" encoding="utf-8"?>
-<p:notes xmlns:a="http://schemas.openxmlformats.org/drawingml/2006/main" xmlns:r="http://schemas.openxmlformats.org/officeDocument/2006/relationships" xmlns:p="http://schemas.openxmlformats.org/presentationml/2006/main">
-  <p:cSld>
-    <p:spTree>
-      <p:nvGrpSpPr>
-        <p:cNvPr id="1" name=""/>
-        <p:cNvGrpSpPr/>
-        <p:nvPr/>
-      </p:nvGrpSpPr>
-      <p:grpSpPr>
-        <a:xfrm>
-          <a:off x="0" y="0"/>
-          <a:ext cx="0" cy="0"/>
-          <a:chOff x="0" y="0"/>
-          <a:chExt cx="0" cy="0"/>
-        </a:xfrm>
-      </p:grpSpPr>
-      <p:sp>
-        <p:nvSpPr>
-          <p:cNvPr id="2" name="Slide Image Placeholder 1"/>
-          <p:cNvSpPr>
-            <a:spLocks noGrp="1" noRot="1" noChangeAspect="1"/>
-          </p:cNvSpPr>
-          <p:nvPr>
-            <p:ph type="sldImg"/>
-          </p:nvPr>
-        </p:nvSpPr>
-        <p:spPr/>
-      </p:sp>
-      <p:sp>
-        <p:nvSpPr>
-          <p:cNvPr id="3" name="Notes Placeholder 2"/>
-          <p:cNvSpPr>
-            <a:spLocks noGrp="1"/>
-          </p:cNvSpPr>
-          <p:nvPr>
-            <p:ph type="body" idx="1"/>
-          </p:nvPr>
-        </p:nvSpPr>
-        <p:spPr/>
-        <p:txBody>
-          <a:bodyPr/>
-          <a:lstStyle/>
-          <a:p>
-            <a:r>
-              <a:rPr lang="en-US" dirty="0"/>
-              <a:t/>
-            </a:r>
-            <a:endParaRPr lang="en-US" dirty="0"/>
-          </a:p>
-        </p:txBody>
-      </p:sp>
-      <p:sp>
-        <p:nvSpPr>
-          <p:cNvPr id="4" name="Slide Number Placeholder 3"/>
-          <p:cNvSpPr>
-            <a:spLocks noGrp="1"/>
-          </p:cNvSpPr>
-          <p:nvPr>
-            <p:ph type="sldNum" sz="quarter" idx="10"/>
-          </p:nvPr>
-        </p:nvSpPr>
-        <p:spPr/>
-        <p:txBody>
-          <a:bodyPr/>
-          <a:lstStyle/>
-          <a:p>
-            <a:fld id="{F7021451-1387-4CA6-816F-3879F97B5CBC}" type="slidenum">
-              <a:rPr lang="en-US"/>
-              <a:t>8</a:t>
             </a:fld>
             <a:endParaRPr lang="en-US"/>
           </a:p>
@@ -1208,6 +872,11 @@
 <file path=ppt/slideMasters/slideMaster1.xml><?xml version="1.0" encoding="utf-8"?>
 <p:sldMaster xmlns:a="http://schemas.openxmlformats.org/drawingml/2006/main" xmlns:r="http://schemas.openxmlformats.org/officeDocument/2006/relationships" xmlns:p="http://schemas.openxmlformats.org/presentationml/2006/main">
   <p:cSld>
+    <p:bg>
+      <p:bgRef idx="1001">
+        <a:schemeClr val="bg1"/>
+      </p:bgRef>
+    </p:bg>
     <p:spTree>
       <p:nvGrpSpPr>
         <p:cNvPr id="1" name=""/>
@@ -1490,6 +1159,7 @@
         <a:solidFill>
           <a:srgbClr val="000000"/>
         </a:solidFill>
+        <a:effectLst/>
       </p:bgPr>
     </p:bg>
     <p:spTree>
@@ -1523,6 +1193,13 @@
           <a:noFill/>
           <a:ln/>
         </p:spPr>
+        <p:txBody>
+          <a:bodyPr/>
+          <a:lstStyle/>
+          <a:p>
+            <a:endParaRPr lang="en-US"/>
+          </a:p>
+        </p:txBody>
       </p:sp>
       <p:sp>
         <p:nvSpPr>
@@ -1545,14 +1222,14 @@
           <a:bodyPr wrap="square" rtlCol="0" anchor="ctr"/>
           <a:lstStyle/>
           <a:p>
-            <a:pPr algn="ctr" indent="0" marL="0">
+            <a:pPr marL="0" indent="0" algn="ctr">
               <a:lnSpc>
                 <a:spcPts val="1890"/>
               </a:lnSpc>
               <a:buNone/>
             </a:pPr>
             <a:r>
-              <a:rPr lang="en-US" sz="1350" spc="-13" kern="0" dirty="0">
+              <a:rPr lang="en-US" sz="1350" kern="0" spc="-13" dirty="0">
                 <a:solidFill>
                   <a:srgbClr val="FFFFFF">
                     <a:alpha val="99000"/>
@@ -1589,14 +1266,14 @@
           <a:bodyPr wrap="square" rtlCol="0" anchor="ctr"/>
           <a:lstStyle/>
           <a:p>
-            <a:pPr algn="ctr" indent="0" marL="0">
+            <a:pPr marL="0" indent="0" algn="ctr">
               <a:lnSpc>
                 <a:spcPts val="4320"/>
               </a:lnSpc>
               <a:buNone/>
             </a:pPr>
             <a:r>
-              <a:rPr lang="en-US" sz="3600" b="1" spc="-72" kern="0" dirty="0">
+              <a:rPr lang="en-US" sz="3600" b="1" kern="0" spc="-72" dirty="0">
                 <a:solidFill>
                   <a:srgbClr val="FFFFFF">
                     <a:alpha val="99000"/>
@@ -1633,14 +1310,14 @@
           <a:bodyPr wrap="square" rtlCol="0" anchor="ctr"/>
           <a:lstStyle/>
           <a:p>
-            <a:pPr algn="ctr" indent="0" marL="0">
+            <a:pPr marL="0" indent="0" algn="ctr">
               <a:lnSpc>
                 <a:spcPts val="1890"/>
               </a:lnSpc>
               <a:buNone/>
             </a:pPr>
             <a:r>
-              <a:rPr lang="en-US" sz="1350" spc="-13" kern="0" dirty="0">
+              <a:rPr lang="en-US" sz="1350" kern="0" spc="-13" dirty="0">
                 <a:solidFill>
                   <a:srgbClr val="FFFFFF">
                     <a:alpha val="99000"/>
@@ -1672,6 +1349,7 @@
         <a:solidFill>
           <a:srgbClr val="000000"/>
         </a:solidFill>
+        <a:effectLst/>
       </p:bgPr>
     </p:bg>
     <p:spTree>
@@ -1709,14 +1387,14 @@
           <a:bodyPr wrap="square" rtlCol="0" anchor="ctr"/>
           <a:lstStyle/>
           <a:p>
-            <a:pPr algn="l" indent="0" marL="0">
+            <a:pPr marL="0" indent="0" algn="l">
               <a:lnSpc>
                 <a:spcPts val="2700"/>
               </a:lnSpc>
               <a:buNone/>
             </a:pPr>
             <a:r>
-              <a:rPr lang="en-US" sz="2250" b="1" spc="-50" kern="0" dirty="0">
+              <a:rPr lang="en-US" sz="2250" b="1" kern="0" spc="-50" dirty="0">
                 <a:solidFill>
                   <a:srgbClr val="FFFFFF">
                     <a:alpha val="99000"/>
@@ -1753,7 +1431,7 @@
           <a:bodyPr wrap="square" rtlCol="0" anchor="ctr"/>
           <a:lstStyle/>
           <a:p>
-            <a:pPr algn="l" marL="342900" indent="-342900">
+            <a:pPr marL="342900" indent="-342900" algn="l">
               <a:lnSpc>
                 <a:spcPts val="1890"/>
               </a:lnSpc>
@@ -1761,7 +1439,7 @@
               <a:buChar char="•"/>
             </a:pPr>
             <a:r>
-              <a:rPr lang="en-US" sz="1350" spc="-13" kern="0" dirty="0">
+              <a:rPr lang="en-US" sz="1350" kern="0" spc="-13" dirty="0">
                 <a:solidFill>
                   <a:srgbClr val="FFFFFF">
                     <a:alpha val="99000"/>
@@ -1776,7 +1454,7 @@
             <a:endParaRPr lang="en-US" sz="1350" dirty="0"/>
           </a:p>
           <a:p>
-            <a:pPr algn="l" marL="342900" indent="-342900">
+            <a:pPr marL="342900" indent="-342900" algn="l">
               <a:lnSpc>
                 <a:spcPts val="1890"/>
               </a:lnSpc>
@@ -1784,7 +1462,7 @@
               <a:buChar char="•"/>
             </a:pPr>
             <a:r>
-              <a:rPr lang="en-US" sz="1350" spc="-13" kern="0" dirty="0">
+              <a:rPr lang="en-US" sz="1350" kern="0" spc="-13" dirty="0">
                 <a:solidFill>
                   <a:srgbClr val="FFFFFF">
                     <a:alpha val="99000"/>
@@ -1799,7 +1477,7 @@
             <a:endParaRPr lang="en-US" sz="1350" dirty="0"/>
           </a:p>
           <a:p>
-            <a:pPr algn="l" marL="342900" indent="-342900">
+            <a:pPr marL="342900" indent="-342900" algn="l">
               <a:lnSpc>
                 <a:spcPts val="1890"/>
               </a:lnSpc>
@@ -1807,7 +1485,7 @@
               <a:buChar char="•"/>
             </a:pPr>
             <a:r>
-              <a:rPr lang="en-US" sz="1350" spc="-13" kern="0" dirty="0">
+              <a:rPr lang="en-US" sz="1350" kern="0" spc="-13" dirty="0">
                 <a:solidFill>
                   <a:srgbClr val="FFFFFF">
                     <a:alpha val="99000"/>
@@ -1822,7 +1500,7 @@
             <a:endParaRPr lang="en-US" sz="1350" dirty="0"/>
           </a:p>
           <a:p>
-            <a:pPr algn="l" marL="342900" indent="-342900">
+            <a:pPr marL="342900" indent="-342900" algn="l">
               <a:lnSpc>
                 <a:spcPts val="1890"/>
               </a:lnSpc>
@@ -1830,7 +1508,7 @@
               <a:buChar char="•"/>
             </a:pPr>
             <a:r>
-              <a:rPr lang="en-US" sz="1350" spc="-13" kern="0" dirty="0">
+              <a:rPr lang="en-US" sz="1350" kern="0" spc="-13" dirty="0">
                 <a:solidFill>
                   <a:srgbClr val="FFFFFF">
                     <a:alpha val="99000"/>
@@ -1845,7 +1523,7 @@
             <a:endParaRPr lang="en-US" sz="1350" dirty="0"/>
           </a:p>
           <a:p>
-            <a:pPr algn="l" marL="342900" indent="-342900">
+            <a:pPr marL="342900" indent="-342900" algn="l">
               <a:lnSpc>
                 <a:spcPts val="1890"/>
               </a:lnSpc>
@@ -1853,7 +1531,7 @@
               <a:buChar char="•"/>
             </a:pPr>
             <a:r>
-              <a:rPr lang="en-US" sz="1350" spc="-13" kern="0" dirty="0">
+              <a:rPr lang="en-US" sz="1350" kern="0" spc="-13" dirty="0">
                 <a:solidFill>
                   <a:srgbClr val="FFFFFF">
                     <a:alpha val="99000"/>
@@ -1885,6 +1563,7 @@
         <a:solidFill>
           <a:srgbClr val="000000"/>
         </a:solidFill>
+        <a:effectLst/>
       </p:bgPr>
     </p:bg>
     <p:spTree>
@@ -1918,6 +1597,13 @@
           <a:noFill/>
           <a:ln/>
         </p:spPr>
+        <p:txBody>
+          <a:bodyPr/>
+          <a:lstStyle/>
+          <a:p>
+            <a:endParaRPr lang="en-US"/>
+          </a:p>
+        </p:txBody>
       </p:sp>
       <p:sp>
         <p:nvSpPr>
@@ -1940,14 +1626,14 @@
           <a:bodyPr wrap="square" rtlCol="0" anchor="ctr"/>
           <a:lstStyle/>
           <a:p>
-            <a:pPr algn="ctr" indent="0" marL="0">
+            <a:pPr marL="0" indent="0" algn="ctr">
               <a:lnSpc>
                 <a:spcPts val="4320"/>
               </a:lnSpc>
               <a:buNone/>
             </a:pPr>
             <a:r>
-              <a:rPr lang="en-US" sz="3600" b="1" spc="-72" kern="0" dirty="0">
+              <a:rPr lang="en-US" sz="3600" b="1" kern="0" spc="-72" dirty="0">
                 <a:solidFill>
                   <a:srgbClr val="FFFFFF">
                     <a:alpha val="99000"/>
@@ -1984,14 +1670,14 @@
           <a:bodyPr wrap="square" rtlCol="0" anchor="ctr"/>
           <a:lstStyle/>
           <a:p>
-            <a:pPr algn="ctr" indent="0" marL="0">
+            <a:pPr marL="0" indent="0" algn="ctr">
               <a:lnSpc>
                 <a:spcPts val="1890"/>
               </a:lnSpc>
               <a:buNone/>
             </a:pPr>
             <a:r>
-              <a:rPr lang="en-US" sz="1350" spc="-13" kern="0" dirty="0">
+              <a:rPr lang="en-US" sz="1350" kern="0" spc="-13" dirty="0">
                 <a:solidFill>
                   <a:srgbClr val="FFFFFF">
                     <a:alpha val="99000"/>
@@ -2023,6 +1709,7 @@
         <a:solidFill>
           <a:srgbClr val="000000"/>
         </a:solidFill>
+        <a:effectLst/>
       </p:bgPr>
     </p:bg>
     <p:spTree>
@@ -2056,6 +1743,13 @@
           <a:noFill/>
           <a:ln/>
         </p:spPr>
+        <p:txBody>
+          <a:bodyPr/>
+          <a:lstStyle/>
+          <a:p>
+            <a:endParaRPr lang="en-US"/>
+          </a:p>
+        </p:txBody>
       </p:sp>
       <p:sp>
         <p:nvSpPr>
@@ -2078,14 +1772,14 @@
           <a:bodyPr wrap="square" rtlCol="0" anchor="ctr"/>
           <a:lstStyle/>
           <a:p>
-            <a:pPr algn="ctr" indent="0" marL="0">
+            <a:pPr marL="0" indent="0" algn="ctr">
               <a:lnSpc>
                 <a:spcPts val="4320"/>
               </a:lnSpc>
               <a:buNone/>
             </a:pPr>
             <a:r>
-              <a:rPr lang="en-US" sz="3600" b="1" spc="-72" kern="0" dirty="0">
+              <a:rPr lang="en-US" sz="3600" b="1" kern="0" spc="-72" dirty="0">
                 <a:solidFill>
                   <a:srgbClr val="FFFFFF">
                     <a:alpha val="99000"/>
@@ -2122,14 +1816,14 @@
           <a:bodyPr wrap="square" rtlCol="0" anchor="ctr"/>
           <a:lstStyle/>
           <a:p>
-            <a:pPr algn="ctr" indent="0" marL="0">
+            <a:pPr marL="0" indent="0" algn="ctr">
               <a:lnSpc>
                 <a:spcPts val="1890"/>
               </a:lnSpc>
               <a:buNone/>
             </a:pPr>
             <a:r>
-              <a:rPr lang="en-US" sz="1350" u="sng" spc="-13" kern="0" dirty="0">
+              <a:rPr lang="en-US" sz="1350" u="sng" kern="0" spc="-13" dirty="0">
                 <a:solidFill>
                   <a:srgbClr val="FFFFFF">
                     <a:alpha val="99000"/>
@@ -2138,7 +1832,7 @@
                 <a:latin typeface="Inter" pitchFamily="34" charset="0"/>
                 <a:ea typeface="Inter" pitchFamily="34" charset="-122"/>
                 <a:cs typeface="Inter" pitchFamily="34" charset="-120"/>
-                <a:hlinkClick r:id="rId1" invalidUrl="" action="" tgtFrame="" tooltip="" history="1" highlightClick="0" endSnd="0">
+                <a:hlinkClick r:id="rId3">
                   <a:extLst>
                     <a:ext uri="{A12FA001-AC4F-418D-AE19-62706E023703}">
                       <ahyp:hlinkClr xmlns:ahyp="http://schemas.microsoft.com/office/drawing/2018/hyperlinkcolor" val="tx"/>
@@ -2162,12 +1856,13 @@
 
 <file path=ppt/slides/slide5.xml><?xml version="1.0" encoding="utf-8"?>
 <p:sld xmlns:a="http://schemas.openxmlformats.org/drawingml/2006/main" xmlns:r="http://schemas.openxmlformats.org/officeDocument/2006/relationships" xmlns:p="http://schemas.openxmlformats.org/presentationml/2006/main">
-  <p:cSld name="Slide 5">
+  <p:cSld name="Slide 6">
     <p:bg>
       <p:bgPr>
         <a:solidFill>
           <a:srgbClr val="000000"/>
         </a:solidFill>
+        <a:effectLst/>
       </p:bgPr>
     </p:bg>
     <p:spTree>
@@ -2184,40 +1879,16 @@
           <a:chExt cx="0" cy="0"/>
         </a:xfrm>
       </p:grpSpPr>
-      <p:pic>
-        <p:nvPicPr>
-          <p:cNvPr id="3" name="Image 0" descr="preencoded.png">    </p:cNvPr>
-          <p:cNvPicPr>
-            <a:picLocks noChangeAspect="1"/>
-          </p:cNvPicPr>
+      <p:sp>
+        <p:nvSpPr>
+          <p:cNvPr id="2" name="Shape 0"/>
+          <p:cNvSpPr/>
           <p:nvPr/>
-        </p:nvPicPr>
-        <p:blipFill>
-          <a:blip r:embed="rId1"/>
-          <a:stretch>
-            <a:fillRect/>
-          </a:stretch>
-        </p:blipFill>
+        </p:nvSpPr>
         <p:spPr>
           <a:xfrm>
-            <a:off x="1709738" y="609600"/>
-            <a:ext cx="5719763" cy="2952750"/>
-          </a:xfrm>
-          <a:prstGeom prst="rect">
-            <a:avLst/>
-          </a:prstGeom>
-        </p:spPr>
-      </p:pic>
-      <p:sp>
-        <p:nvSpPr>
-          <p:cNvPr id="4" name="Text 0"/>
-          <p:cNvSpPr/>
-          <p:nvPr/>
-        </p:nvSpPr>
-        <p:spPr>
-          <a:xfrm>
-            <a:off x="1333500" y="3986213"/>
-            <a:ext cx="6934200" cy="547688"/>
+            <a:off x="4610100" y="1562100"/>
+            <a:ext cx="3238500" cy="914400"/>
           </a:xfrm>
           <a:prstGeom prst="rect">
             <a:avLst/>
@@ -2226,17 +1897,67 @@
           <a:ln/>
         </p:spPr>
         <p:txBody>
+          <a:bodyPr/>
+          <a:lstStyle/>
+          <a:p>
+            <a:endParaRPr lang="en-US"/>
+          </a:p>
+        </p:txBody>
+      </p:sp>
+      <p:sp>
+        <p:nvSpPr>
+          <p:cNvPr id="3" name="Shape 1"/>
+          <p:cNvSpPr/>
+          <p:nvPr/>
+        </p:nvSpPr>
+        <p:spPr>
+          <a:xfrm>
+            <a:off x="4610100" y="2814638"/>
+            <a:ext cx="3238500" cy="914400"/>
+          </a:xfrm>
+          <a:prstGeom prst="rect">
+            <a:avLst/>
+          </a:prstGeom>
+          <a:noFill/>
+          <a:ln/>
+        </p:spPr>
+        <p:txBody>
+          <a:bodyPr/>
+          <a:lstStyle/>
+          <a:p>
+            <a:endParaRPr lang="en-US"/>
+          </a:p>
+        </p:txBody>
+      </p:sp>
+      <p:sp>
+        <p:nvSpPr>
+          <p:cNvPr id="4" name="Text 2"/>
+          <p:cNvSpPr/>
+          <p:nvPr/>
+        </p:nvSpPr>
+        <p:spPr>
+          <a:xfrm>
+            <a:off x="609600" y="2433638"/>
+            <a:ext cx="3124200" cy="276225"/>
+          </a:xfrm>
+          <a:prstGeom prst="rect">
+            <a:avLst/>
+          </a:prstGeom>
+          <a:noFill/>
+          <a:ln/>
+        </p:spPr>
+        <p:txBody>
           <a:bodyPr wrap="square" rtlCol="0" anchor="ctr"/>
           <a:lstStyle/>
           <a:p>
-            <a:pPr algn="ctr" indent="0" marL="0">
+            <a:pPr marL="0" indent="0" algn="l">
               <a:lnSpc>
-                <a:spcPts val="4320"/>
+                <a:spcPts val="2160"/>
               </a:lnSpc>
               <a:buNone/>
             </a:pPr>
             <a:r>
-              <a:rPr lang="en-US" sz="3600" b="1" u="sng" spc="-72" kern="0" dirty="0">
+              <a:rPr lang="en-US" sz="1800" b="1" kern="0" spc="-36" dirty="0">
                 <a:solidFill>
                   <a:srgbClr val="FFFFFF">
                     <a:alpha val="99000"/>
@@ -2245,17 +1966,274 @@
                 <a:latin typeface="Inter" pitchFamily="34" charset="0"/>
                 <a:ea typeface="Inter" pitchFamily="34" charset="-122"/>
                 <a:cs typeface="Inter" pitchFamily="34" charset="-120"/>
-                <a:hlinkClick r:id="rId2" invalidUrl="" action="" tgtFrame="" tooltip="" history="1" highlightClick="0" endSnd="0">
-                  <a:extLst>
-                    <a:ext uri="{A12FA001-AC4F-418D-AE19-62706E023703}">
-                      <ahyp:hlinkClr xmlns:ahyp="http://schemas.microsoft.com/office/drawing/2018/hyperlinkcolor" val="tx"/>
-                    </a:ext>
-                  </a:extLst>
-                </a:hlinkClick>
               </a:rPr>
-              <a:t>https://discord.gg/T8zN36C6</a:t>
+              <a:t>How the course works?</a:t>
             </a:r>
-            <a:endParaRPr lang="en-US" sz="3600" dirty="0"/>
+            <a:endParaRPr lang="en-US" sz="1800" dirty="0"/>
+          </a:p>
+        </p:txBody>
+      </p:sp>
+      <p:sp>
+        <p:nvSpPr>
+          <p:cNvPr id="5" name="Text 3"/>
+          <p:cNvSpPr/>
+          <p:nvPr/>
+        </p:nvSpPr>
+        <p:spPr>
+          <a:xfrm>
+            <a:off x="4610100" y="2814638"/>
+            <a:ext cx="3695700" cy="228600"/>
+          </a:xfrm>
+          <a:prstGeom prst="rect">
+            <a:avLst/>
+          </a:prstGeom>
+          <a:noFill/>
+          <a:ln/>
+        </p:spPr>
+        <p:txBody>
+          <a:bodyPr wrap="square" rtlCol="0" anchor="ctr"/>
+          <a:lstStyle/>
+          <a:p>
+            <a:pPr marL="0" indent="0" algn="l">
+              <a:lnSpc>
+                <a:spcPts val="1782"/>
+              </a:lnSpc>
+              <a:buNone/>
+            </a:pPr>
+            <a:r>
+              <a:rPr lang="en-US" sz="1350" b="1" kern="0" spc="-27" dirty="0">
+                <a:solidFill>
+                  <a:srgbClr val="FFFFFF">
+                    <a:alpha val="99000"/>
+                  </a:srgbClr>
+                </a:solidFill>
+                <a:latin typeface="Inter" pitchFamily="34" charset="0"/>
+                <a:ea typeface="Inter" pitchFamily="34" charset="-122"/>
+                <a:cs typeface="Inter" pitchFamily="34" charset="-120"/>
+              </a:rPr>
+              <a:t>80%</a:t>
+            </a:r>
+            <a:endParaRPr lang="en-US" sz="1350" dirty="0"/>
+          </a:p>
+        </p:txBody>
+      </p:sp>
+      <p:sp>
+        <p:nvSpPr>
+          <p:cNvPr id="6" name="Text 4"/>
+          <p:cNvSpPr/>
+          <p:nvPr/>
+        </p:nvSpPr>
+        <p:spPr>
+          <a:xfrm>
+            <a:off x="4610100" y="3119438"/>
+            <a:ext cx="3695700" cy="228600"/>
+          </a:xfrm>
+          <a:prstGeom prst="rect">
+            <a:avLst/>
+          </a:prstGeom>
+          <a:noFill/>
+          <a:ln/>
+        </p:spPr>
+        <p:txBody>
+          <a:bodyPr wrap="square" rtlCol="0" anchor="ctr"/>
+          <a:lstStyle/>
+          <a:p>
+            <a:pPr marL="0" indent="0" algn="l">
+              <a:lnSpc>
+                <a:spcPts val="1782"/>
+              </a:lnSpc>
+              <a:buNone/>
+            </a:pPr>
+            <a:r>
+              <a:rPr lang="en-US" sz="1350" kern="0" spc="-27" dirty="0">
+                <a:solidFill>
+                  <a:srgbClr val="FFFFFF">
+                    <a:alpha val="99000"/>
+                  </a:srgbClr>
+                </a:solidFill>
+                <a:latin typeface="Inter" pitchFamily="34" charset="0"/>
+                <a:ea typeface="Inter" pitchFamily="34" charset="-122"/>
+                <a:cs typeface="Inter" pitchFamily="34" charset="-120"/>
+              </a:rPr>
+              <a:t>Practical (How) -- Unity</a:t>
+            </a:r>
+            <a:endParaRPr lang="en-US" sz="1350" dirty="0"/>
+          </a:p>
+        </p:txBody>
+      </p:sp>
+      <p:sp>
+        <p:nvSpPr>
+          <p:cNvPr id="7" name="Text 5"/>
+          <p:cNvSpPr/>
+          <p:nvPr/>
+        </p:nvSpPr>
+        <p:spPr>
+          <a:xfrm>
+            <a:off x="4610100" y="3424238"/>
+            <a:ext cx="3695700" cy="304800"/>
+          </a:xfrm>
+          <a:prstGeom prst="rect">
+            <a:avLst/>
+          </a:prstGeom>
+          <a:noFill/>
+          <a:ln/>
+        </p:spPr>
+        <p:txBody>
+          <a:bodyPr wrap="square" rtlCol="0" anchor="ctr"/>
+          <a:lstStyle/>
+          <a:p>
+            <a:pPr marL="0" indent="0" algn="l">
+              <a:lnSpc>
+                <a:spcPts val="1206"/>
+              </a:lnSpc>
+              <a:buNone/>
+            </a:pPr>
+            <a:r>
+              <a:rPr lang="en-US" sz="900" kern="0" spc="-5" dirty="0">
+                <a:solidFill>
+                  <a:srgbClr val="FFFFFF">
+                    <a:alpha val="99000"/>
+                  </a:srgbClr>
+                </a:solidFill>
+                <a:latin typeface="Inter" pitchFamily="34" charset="0"/>
+                <a:ea typeface="Inter" pitchFamily="34" charset="-122"/>
+                <a:cs typeface="Inter" pitchFamily="34" charset="-120"/>
+              </a:rPr>
+              <a:t>Editor, Scripting, Player control, UI, Animation, Cameras, Lightning, .. </a:t>
+            </a:r>
+            <a:endParaRPr lang="en-US" sz="900" dirty="0"/>
+          </a:p>
+        </p:txBody>
+      </p:sp>
+      <p:sp>
+        <p:nvSpPr>
+          <p:cNvPr id="8" name="Text 6"/>
+          <p:cNvSpPr/>
+          <p:nvPr/>
+        </p:nvSpPr>
+        <p:spPr>
+          <a:xfrm>
+            <a:off x="4610100" y="1562100"/>
+            <a:ext cx="3695700" cy="228600"/>
+          </a:xfrm>
+          <a:prstGeom prst="rect">
+            <a:avLst/>
+          </a:prstGeom>
+          <a:noFill/>
+          <a:ln/>
+        </p:spPr>
+        <p:txBody>
+          <a:bodyPr wrap="square" rtlCol="0" anchor="ctr"/>
+          <a:lstStyle/>
+          <a:p>
+            <a:pPr marL="0" indent="0" algn="l">
+              <a:lnSpc>
+                <a:spcPts val="1782"/>
+              </a:lnSpc>
+              <a:buNone/>
+            </a:pPr>
+            <a:r>
+              <a:rPr lang="en-US" sz="1350" b="1" kern="0" spc="-27" dirty="0">
+                <a:solidFill>
+                  <a:srgbClr val="FFFFFF">
+                    <a:alpha val="99000"/>
+                  </a:srgbClr>
+                </a:solidFill>
+                <a:latin typeface="Inter" pitchFamily="34" charset="0"/>
+                <a:ea typeface="Inter" pitchFamily="34" charset="-122"/>
+                <a:cs typeface="Inter" pitchFamily="34" charset="-120"/>
+              </a:rPr>
+              <a:t>20%</a:t>
+            </a:r>
+            <a:endParaRPr lang="en-US" sz="1350" dirty="0"/>
+          </a:p>
+        </p:txBody>
+      </p:sp>
+      <p:sp>
+        <p:nvSpPr>
+          <p:cNvPr id="9" name="Text 7"/>
+          <p:cNvSpPr/>
+          <p:nvPr/>
+        </p:nvSpPr>
+        <p:spPr>
+          <a:xfrm>
+            <a:off x="4610100" y="1866900"/>
+            <a:ext cx="3695700" cy="228600"/>
+          </a:xfrm>
+          <a:prstGeom prst="rect">
+            <a:avLst/>
+          </a:prstGeom>
+          <a:noFill/>
+          <a:ln/>
+        </p:spPr>
+        <p:txBody>
+          <a:bodyPr wrap="square" rtlCol="0" anchor="ctr"/>
+          <a:lstStyle/>
+          <a:p>
+            <a:pPr marL="0" indent="0" algn="l">
+              <a:lnSpc>
+                <a:spcPts val="1782"/>
+              </a:lnSpc>
+              <a:buNone/>
+            </a:pPr>
+            <a:r>
+              <a:rPr lang="en-US" sz="1350" kern="0" spc="-27" dirty="0">
+                <a:solidFill>
+                  <a:srgbClr val="FFFFFF">
+                    <a:alpha val="99000"/>
+                  </a:srgbClr>
+                </a:solidFill>
+                <a:latin typeface="Inter" pitchFamily="34" charset="0"/>
+                <a:ea typeface="Inter" pitchFamily="34" charset="-122"/>
+                <a:cs typeface="Inter" pitchFamily="34" charset="-120"/>
+              </a:rPr>
+              <a:t>Theoretical (What/Why)</a:t>
+            </a:r>
+            <a:endParaRPr lang="en-US" sz="1350" dirty="0"/>
+          </a:p>
+        </p:txBody>
+      </p:sp>
+      <p:sp>
+        <p:nvSpPr>
+          <p:cNvPr id="10" name="Text 8"/>
+          <p:cNvSpPr/>
+          <p:nvPr/>
+        </p:nvSpPr>
+        <p:spPr>
+          <a:xfrm>
+            <a:off x="4610100" y="2171700"/>
+            <a:ext cx="3695700" cy="304800"/>
+          </a:xfrm>
+          <a:prstGeom prst="rect">
+            <a:avLst/>
+          </a:prstGeom>
+          <a:noFill/>
+          <a:ln/>
+        </p:spPr>
+        <p:txBody>
+          <a:bodyPr wrap="square" rtlCol="0" anchor="ctr"/>
+          <a:lstStyle/>
+          <a:p>
+            <a:pPr marL="0" indent="0" algn="l">
+              <a:lnSpc>
+                <a:spcPts val="1206"/>
+              </a:lnSpc>
+              <a:buNone/>
+            </a:pPr>
+            <a:r>
+              <a:rPr lang="en-US" sz="900" kern="0" spc="-5" dirty="0">
+                <a:solidFill>
+                  <a:srgbClr val="FFFFFF">
+                    <a:alpha val="99000"/>
+                  </a:srgbClr>
+                </a:solidFill>
+                <a:latin typeface="Inter" pitchFamily="34" charset="0"/>
+                <a:ea typeface="Inter" pitchFamily="34" charset="-122"/>
+                <a:cs typeface="Inter" pitchFamily="34" charset="-120"/>
+              </a:rPr>
+              <a:t>History of Game Dev, Game Dev Principles, Engines, Graphics, Rendering, AI for Games, Production, .. </a:t>
+            </a:r>
+            <a:endParaRPr lang="en-US" sz="900" dirty="0"/>
           </a:p>
         </p:txBody>
       </p:sp>
@@ -2269,12 +2247,13 @@
 
 <file path=ppt/slides/slide6.xml><?xml version="1.0" encoding="utf-8"?>
 <p:sld xmlns:a="http://schemas.openxmlformats.org/drawingml/2006/main" xmlns:r="http://schemas.openxmlformats.org/officeDocument/2006/relationships" xmlns:p="http://schemas.openxmlformats.org/presentationml/2006/main">
-  <p:cSld name="Slide 6">
+  <p:cSld name="Slide 7">
     <p:bg>
       <p:bgPr>
         <a:solidFill>
           <a:srgbClr val="000000"/>
         </a:solidFill>
+        <a:effectLst/>
       </p:bgPr>
     </p:bg>
     <p:spTree>
@@ -2293,14 +2272,72 @@
       </p:grpSpPr>
       <p:sp>
         <p:nvSpPr>
-          <p:cNvPr id="2" name="Shape 0"/>
+          <p:cNvPr id="3" name="Shape 1"/>
           <p:cNvSpPr/>
           <p:nvPr/>
         </p:nvSpPr>
         <p:spPr>
           <a:xfrm>
-            <a:off x="4610100" y="1562100"/>
-            <a:ext cx="3238500" cy="914400"/>
+            <a:off x="673608" y="1304925"/>
+            <a:ext cx="2438400" cy="3228975"/>
+          </a:xfrm>
+          <a:prstGeom prst="roundRect">
+            <a:avLst>
+              <a:gd name="adj" fmla="val 6000"/>
+            </a:avLst>
+          </a:prstGeom>
+          <a:solidFill>
+            <a:srgbClr val="424242"/>
+          </a:solidFill>
+          <a:ln/>
+        </p:spPr>
+        <p:txBody>
+          <a:bodyPr/>
+          <a:lstStyle/>
+          <a:p>
+            <a:endParaRPr lang="en-US"/>
+          </a:p>
+        </p:txBody>
+      </p:sp>
+      <p:sp>
+        <p:nvSpPr>
+          <p:cNvPr id="4" name="Shape 2"/>
+          <p:cNvSpPr/>
+          <p:nvPr/>
+        </p:nvSpPr>
+        <p:spPr>
+          <a:xfrm>
+            <a:off x="3278124" y="1304925"/>
+            <a:ext cx="5332476" cy="3228975"/>
+          </a:xfrm>
+          <a:prstGeom prst="roundRect">
+            <a:avLst>
+              <a:gd name="adj" fmla="val 6000"/>
+            </a:avLst>
+          </a:prstGeom>
+          <a:solidFill>
+            <a:srgbClr val="424242"/>
+          </a:solidFill>
+          <a:ln/>
+        </p:spPr>
+        <p:txBody>
+          <a:bodyPr/>
+          <a:lstStyle/>
+          <a:p>
+            <a:endParaRPr lang="en-US"/>
+          </a:p>
+        </p:txBody>
+      </p:sp>
+      <p:sp>
+        <p:nvSpPr>
+          <p:cNvPr id="5" name="Text 3"/>
+          <p:cNvSpPr/>
+          <p:nvPr/>
+        </p:nvSpPr>
+        <p:spPr>
+          <a:xfrm>
+            <a:off x="609600" y="609600"/>
+            <a:ext cx="8001000" cy="276225"/>
           </a:xfrm>
           <a:prstGeom prst="rect">
             <a:avLst/>
@@ -2308,54 +2345,18 @@
           <a:noFill/>
           <a:ln/>
         </p:spPr>
-      </p:sp>
-      <p:sp>
-        <p:nvSpPr>
-          <p:cNvPr id="3" name="Shape 1"/>
-          <p:cNvSpPr/>
-          <p:nvPr/>
-        </p:nvSpPr>
-        <p:spPr>
-          <a:xfrm>
-            <a:off x="4610100" y="2814638"/>
-            <a:ext cx="3238500" cy="914400"/>
-          </a:xfrm>
-          <a:prstGeom prst="rect">
-            <a:avLst/>
-          </a:prstGeom>
-          <a:noFill/>
-          <a:ln/>
-        </p:spPr>
-      </p:sp>
-      <p:sp>
-        <p:nvSpPr>
-          <p:cNvPr id="4" name="Text 2"/>
-          <p:cNvSpPr/>
-          <p:nvPr/>
-        </p:nvSpPr>
-        <p:spPr>
-          <a:xfrm>
-            <a:off x="609600" y="2433638"/>
-            <a:ext cx="3124200" cy="276225"/>
-          </a:xfrm>
-          <a:prstGeom prst="rect">
-            <a:avLst/>
-          </a:prstGeom>
-          <a:noFill/>
-          <a:ln/>
-        </p:spPr>
         <p:txBody>
           <a:bodyPr wrap="square" rtlCol="0" anchor="ctr"/>
           <a:lstStyle/>
           <a:p>
-            <a:pPr algn="l" indent="0" marL="0">
+            <a:pPr marL="0" indent="0" algn="l">
               <a:lnSpc>
                 <a:spcPts val="2160"/>
               </a:lnSpc>
               <a:buNone/>
             </a:pPr>
             <a:r>
-              <a:rPr lang="en-US" sz="1800" b="1" spc="-36" kern="0" dirty="0">
+              <a:rPr lang="en-US" sz="1800" b="1" kern="0" spc="-36" dirty="0">
                 <a:solidFill>
                   <a:srgbClr val="FFFFFF">
                     <a:alpha val="99000"/>
@@ -2365,7 +2366,7 @@
                 <a:ea typeface="Inter" pitchFamily="34" charset="-122"/>
                 <a:cs typeface="Inter" pitchFamily="34" charset="-120"/>
               </a:rPr>
-              <a:t>How the course works?</a:t>
+              <a:t>Lecture structure</a:t>
             </a:r>
             <a:endParaRPr lang="en-US" sz="1800" dirty="0"/>
           </a:p>
@@ -2373,14 +2374,14 @@
       </p:sp>
       <p:sp>
         <p:nvSpPr>
-          <p:cNvPr id="5" name="Text 3"/>
+          <p:cNvPr id="6" name="Text 4"/>
           <p:cNvSpPr/>
           <p:nvPr/>
         </p:nvSpPr>
         <p:spPr>
           <a:xfrm>
-            <a:off x="4610100" y="2814638"/>
-            <a:ext cx="3695700" cy="228600"/>
+            <a:off x="3596195" y="1595438"/>
+            <a:ext cx="2465387" cy="228600"/>
           </a:xfrm>
           <a:prstGeom prst="rect">
             <a:avLst/>
@@ -2392,14 +2393,14 @@
           <a:bodyPr wrap="square" rtlCol="0" anchor="ctr"/>
           <a:lstStyle/>
           <a:p>
-            <a:pPr algn="l" indent="0" marL="0">
+            <a:pPr marL="0" indent="0" algn="l">
               <a:lnSpc>
                 <a:spcPts val="1782"/>
               </a:lnSpc>
               <a:buNone/>
             </a:pPr>
             <a:r>
-              <a:rPr lang="en-US" sz="1350" b="1" spc="-27" kern="0" dirty="0">
+              <a:rPr lang="en-US" sz="1350" kern="0" spc="-27" dirty="0">
                 <a:solidFill>
                   <a:srgbClr val="FFFFFF">
                     <a:alpha val="99000"/>
@@ -2409,7 +2410,7 @@
                 <a:ea typeface="Inter" pitchFamily="34" charset="-122"/>
                 <a:cs typeface="Inter" pitchFamily="34" charset="-120"/>
               </a:rPr>
-              <a:t>80%</a:t>
+              <a:t>~40m </a:t>
             </a:r>
             <a:endParaRPr lang="en-US" sz="1350" dirty="0"/>
           </a:p>
@@ -2417,14 +2418,14 @@
       </p:sp>
       <p:sp>
         <p:nvSpPr>
-          <p:cNvPr id="6" name="Text 4"/>
+          <p:cNvPr id="7" name="Text 5"/>
           <p:cNvSpPr/>
           <p:nvPr/>
         </p:nvSpPr>
         <p:spPr>
           <a:xfrm>
-            <a:off x="4610100" y="3119438"/>
-            <a:ext cx="3695700" cy="228600"/>
+            <a:off x="3596195" y="3667125"/>
+            <a:ext cx="2465387" cy="228600"/>
           </a:xfrm>
           <a:prstGeom prst="rect">
             <a:avLst/>
@@ -2436,14 +2437,14 @@
           <a:bodyPr wrap="square" rtlCol="0" anchor="ctr"/>
           <a:lstStyle/>
           <a:p>
-            <a:pPr algn="l" indent="0" marL="0">
+            <a:pPr marL="0" indent="0" algn="l">
               <a:lnSpc>
                 <a:spcPts val="1782"/>
               </a:lnSpc>
               <a:buNone/>
             </a:pPr>
             <a:r>
-              <a:rPr lang="en-US" sz="1350" spc="-27" kern="0" dirty="0">
+              <a:rPr lang="en-US" sz="1350" kern="0" spc="-27" dirty="0">
                 <a:solidFill>
                   <a:srgbClr val="FFFFFF">
                     <a:alpha val="99000"/>
@@ -2453,7 +2454,7 @@
                 <a:ea typeface="Inter" pitchFamily="34" charset="-122"/>
                 <a:cs typeface="Inter" pitchFamily="34" charset="-120"/>
               </a:rPr>
-              <a:t>Practical (How) -- Unity</a:t>
+              <a:t>You:</a:t>
             </a:r>
             <a:endParaRPr lang="en-US" sz="1350" dirty="0"/>
           </a:p>
@@ -2461,14 +2462,14 @@
       </p:sp>
       <p:sp>
         <p:nvSpPr>
-          <p:cNvPr id="7" name="Text 5"/>
+          <p:cNvPr id="8" name="Text 6"/>
           <p:cNvSpPr/>
           <p:nvPr/>
         </p:nvSpPr>
         <p:spPr>
           <a:xfrm>
-            <a:off x="4610100" y="3424238"/>
-            <a:ext cx="3695700" cy="304800"/>
+            <a:off x="3596195" y="1824038"/>
+            <a:ext cx="2465387" cy="276225"/>
           </a:xfrm>
           <a:prstGeom prst="rect">
             <a:avLst/>
@@ -2480,14 +2481,14 @@
           <a:bodyPr wrap="square" rtlCol="0" anchor="ctr"/>
           <a:lstStyle/>
           <a:p>
-            <a:pPr algn="l" indent="0" marL="0">
+            <a:pPr marL="0" indent="0" algn="l">
               <a:lnSpc>
-                <a:spcPts val="1206"/>
+                <a:spcPts val="2160"/>
               </a:lnSpc>
               <a:buNone/>
             </a:pPr>
             <a:r>
-              <a:rPr lang="en-US" sz="900" spc="-5" kern="0" dirty="0">
+              <a:rPr lang="en-US" sz="1800" b="1" kern="0" spc="-36" dirty="0">
                 <a:solidFill>
                   <a:srgbClr val="FFFFFF">
                     <a:alpha val="99000"/>
@@ -2497,22 +2498,22 @@
                 <a:ea typeface="Inter" pitchFamily="34" charset="-122"/>
                 <a:cs typeface="Inter" pitchFamily="34" charset="-120"/>
               </a:rPr>
-              <a:t>Editor, Scripting, Player control, UI, Animation, Cameras, Lightning, .. </a:t>
+              <a:t>Hands-On</a:t>
             </a:r>
-            <a:endParaRPr lang="en-US" sz="900" dirty="0"/>
-          </a:p>
-        </p:txBody>
-      </p:sp>
-      <p:sp>
-        <p:nvSpPr>
-          <p:cNvPr id="8" name="Text 6"/>
+            <a:endParaRPr lang="en-US" sz="1800" dirty="0"/>
+          </a:p>
+        </p:txBody>
+      </p:sp>
+      <p:sp>
+        <p:nvSpPr>
+          <p:cNvPr id="9" name="Text 7"/>
           <p:cNvSpPr/>
           <p:nvPr/>
         </p:nvSpPr>
         <p:spPr>
           <a:xfrm>
-            <a:off x="4610100" y="1562100"/>
-            <a:ext cx="3695700" cy="228600"/>
+            <a:off x="3596195" y="3895725"/>
+            <a:ext cx="2465387" cy="276225"/>
           </a:xfrm>
           <a:prstGeom prst="rect">
             <a:avLst/>
@@ -2524,14 +2525,14 @@
           <a:bodyPr wrap="square" rtlCol="0" anchor="ctr"/>
           <a:lstStyle/>
           <a:p>
-            <a:pPr algn="l" indent="0" marL="0">
+            <a:pPr marL="0" indent="0" algn="l">
               <a:lnSpc>
-                <a:spcPts val="1782"/>
+                <a:spcPts val="2160"/>
               </a:lnSpc>
               <a:buNone/>
             </a:pPr>
             <a:r>
-              <a:rPr lang="en-US" sz="1350" b="1" spc="-27" kern="0" dirty="0">
+              <a:rPr lang="en-US" sz="1800" b="1" kern="0" spc="-36" dirty="0">
                 <a:solidFill>
                   <a:srgbClr val="FFFFFF">
                     <a:alpha val="99000"/>
@@ -2541,22 +2542,22 @@
                 <a:ea typeface="Inter" pitchFamily="34" charset="-122"/>
                 <a:cs typeface="Inter" pitchFamily="34" charset="-120"/>
               </a:rPr>
-              <a:t>20%</a:t>
+              <a:t>Practice! </a:t>
             </a:r>
-            <a:endParaRPr lang="en-US" sz="1350" dirty="0"/>
-          </a:p>
-        </p:txBody>
-      </p:sp>
-      <p:sp>
-        <p:nvSpPr>
-          <p:cNvPr id="9" name="Text 7"/>
+            <a:endParaRPr lang="en-US" sz="1800" dirty="0"/>
+          </a:p>
+        </p:txBody>
+      </p:sp>
+      <p:sp>
+        <p:nvSpPr>
+          <p:cNvPr id="10" name="Text 8"/>
           <p:cNvSpPr/>
           <p:nvPr/>
         </p:nvSpPr>
         <p:spPr>
           <a:xfrm>
-            <a:off x="4610100" y="1866900"/>
-            <a:ext cx="3695700" cy="228600"/>
+            <a:off x="902208" y="1595438"/>
+            <a:ext cx="2465387" cy="228600"/>
           </a:xfrm>
           <a:prstGeom prst="rect">
             <a:avLst/>
@@ -2568,14 +2569,14 @@
           <a:bodyPr wrap="square" rtlCol="0" anchor="ctr"/>
           <a:lstStyle/>
           <a:p>
-            <a:pPr algn="l" indent="0" marL="0">
+            <a:pPr marL="0" indent="0" algn="l">
               <a:lnSpc>
                 <a:spcPts val="1782"/>
               </a:lnSpc>
               <a:buNone/>
             </a:pPr>
             <a:r>
-              <a:rPr lang="en-US" sz="1350" spc="-27" kern="0" dirty="0">
+              <a:rPr lang="en-US" sz="1350" kern="0" spc="-27" dirty="0">
                 <a:solidFill>
                   <a:srgbClr val="FFFFFF">
                     <a:alpha val="99000"/>
@@ -2585,7 +2586,7 @@
                 <a:ea typeface="Inter" pitchFamily="34" charset="-122"/>
                 <a:cs typeface="Inter" pitchFamily="34" charset="-120"/>
               </a:rPr>
-              <a:t>Theoretical (What/Why)</a:t>
+              <a:t>~20m </a:t>
             </a:r>
             <a:endParaRPr lang="en-US" sz="1350" dirty="0"/>
           </a:p>
@@ -2593,14 +2594,14 @@
       </p:sp>
       <p:sp>
         <p:nvSpPr>
-          <p:cNvPr id="10" name="Text 8"/>
+          <p:cNvPr id="11" name="Text 9"/>
           <p:cNvSpPr/>
           <p:nvPr/>
         </p:nvSpPr>
         <p:spPr>
           <a:xfrm>
-            <a:off x="4610100" y="2171700"/>
-            <a:ext cx="3695700" cy="304800"/>
+            <a:off x="902208" y="3667125"/>
+            <a:ext cx="2465387" cy="228600"/>
           </a:xfrm>
           <a:prstGeom prst="rect">
             <a:avLst/>
@@ -2612,14 +2613,14 @@
           <a:bodyPr wrap="square" rtlCol="0" anchor="ctr"/>
           <a:lstStyle/>
           <a:p>
-            <a:pPr algn="l" indent="0" marL="0">
+            <a:pPr marL="0" indent="0" algn="l">
               <a:lnSpc>
-                <a:spcPts val="1206"/>
+                <a:spcPts val="1782"/>
               </a:lnSpc>
               <a:buNone/>
             </a:pPr>
             <a:r>
-              <a:rPr lang="en-US" sz="900" spc="-5" kern="0" dirty="0">
+              <a:rPr lang="en-US" sz="1350" kern="0" spc="-27" dirty="0">
                 <a:solidFill>
                   <a:srgbClr val="FFFFFF">
                     <a:alpha val="99000"/>
@@ -2629,9 +2630,97 @@
                 <a:ea typeface="Inter" pitchFamily="34" charset="-122"/>
                 <a:cs typeface="Inter" pitchFamily="34" charset="-120"/>
               </a:rPr>
-              <a:t>History of Game Dev, Game Dev Principles, Engines, Graphics, Rendering, AI for Games, Production, .. </a:t>
+              <a:t>You:</a:t>
             </a:r>
-            <a:endParaRPr lang="en-US" sz="900" dirty="0"/>
+            <a:endParaRPr lang="en-US" sz="1350" dirty="0"/>
+          </a:p>
+        </p:txBody>
+      </p:sp>
+      <p:sp>
+        <p:nvSpPr>
+          <p:cNvPr id="12" name="Text 10"/>
+          <p:cNvSpPr/>
+          <p:nvPr/>
+        </p:nvSpPr>
+        <p:spPr>
+          <a:xfrm>
+            <a:off x="902208" y="1824038"/>
+            <a:ext cx="2465387" cy="276225"/>
+          </a:xfrm>
+          <a:prstGeom prst="rect">
+            <a:avLst/>
+          </a:prstGeom>
+          <a:noFill/>
+          <a:ln/>
+        </p:spPr>
+        <p:txBody>
+          <a:bodyPr wrap="square" rtlCol="0" anchor="ctr"/>
+          <a:lstStyle/>
+          <a:p>
+            <a:pPr marL="0" indent="0" algn="l">
+              <a:lnSpc>
+                <a:spcPts val="2160"/>
+              </a:lnSpc>
+              <a:buNone/>
+            </a:pPr>
+            <a:r>
+              <a:rPr lang="en-US" sz="1800" b="1" kern="0" spc="-36" dirty="0">
+                <a:solidFill>
+                  <a:srgbClr val="FFFFFF">
+                    <a:alpha val="99000"/>
+                  </a:srgbClr>
+                </a:solidFill>
+                <a:latin typeface="Inter" pitchFamily="34" charset="0"/>
+                <a:ea typeface="Inter" pitchFamily="34" charset="-122"/>
+                <a:cs typeface="Inter" pitchFamily="34" charset="-120"/>
+              </a:rPr>
+              <a:t>Demo</a:t>
+            </a:r>
+            <a:endParaRPr lang="en-US" sz="1800" dirty="0"/>
+          </a:p>
+        </p:txBody>
+      </p:sp>
+      <p:sp>
+        <p:nvSpPr>
+          <p:cNvPr id="13" name="Text 11"/>
+          <p:cNvSpPr/>
+          <p:nvPr/>
+        </p:nvSpPr>
+        <p:spPr>
+          <a:xfrm>
+            <a:off x="902208" y="3895725"/>
+            <a:ext cx="2465387" cy="276225"/>
+          </a:xfrm>
+          <a:prstGeom prst="rect">
+            <a:avLst/>
+          </a:prstGeom>
+          <a:noFill/>
+          <a:ln/>
+        </p:spPr>
+        <p:txBody>
+          <a:bodyPr wrap="square" rtlCol="0" anchor="ctr"/>
+          <a:lstStyle/>
+          <a:p>
+            <a:pPr marL="0" indent="0" algn="l">
+              <a:lnSpc>
+                <a:spcPts val="2160"/>
+              </a:lnSpc>
+              <a:buNone/>
+            </a:pPr>
+            <a:r>
+              <a:rPr lang="en-US" sz="1800" b="1" kern="0" spc="-36" dirty="0">
+                <a:solidFill>
+                  <a:srgbClr val="FFFFFF">
+                    <a:alpha val="99000"/>
+                  </a:srgbClr>
+                </a:solidFill>
+                <a:latin typeface="Inter" pitchFamily="34" charset="0"/>
+                <a:ea typeface="Inter" pitchFamily="34" charset="-122"/>
+                <a:cs typeface="Inter" pitchFamily="34" charset="-120"/>
+              </a:rPr>
+              <a:t>Follow along</a:t>
+            </a:r>
+            <a:endParaRPr lang="en-US" sz="1800" dirty="0"/>
           </a:p>
         </p:txBody>
       </p:sp>
@@ -2645,12 +2734,13 @@
 
 <file path=ppt/slides/slide7.xml><?xml version="1.0" encoding="utf-8"?>
 <p:sld xmlns:a="http://schemas.openxmlformats.org/drawingml/2006/main" xmlns:r="http://schemas.openxmlformats.org/officeDocument/2006/relationships" xmlns:p="http://schemas.openxmlformats.org/presentationml/2006/main">
-  <p:cSld name="Slide 7">
+  <p:cSld name="Slide 8">
     <p:bg>
       <p:bgPr>
         <a:solidFill>
           <a:srgbClr val="000000"/>
         </a:solidFill>
+        <a:effectLst/>
       </p:bgPr>
     </p:bg>
     <p:spTree>
@@ -2675,676 +2765,6 @@
         </p:nvSpPr>
         <p:spPr>
           <a:xfrm>
-            <a:off x="609600" y="1309688"/>
-            <a:ext cx="2438400" cy="3228975"/>
-          </a:xfrm>
-          <a:prstGeom prst="roundRect">
-            <a:avLst>
-              <a:gd name="adj" fmla="val 6000"/>
-            </a:avLst>
-          </a:prstGeom>
-          <a:solidFill>
-            <a:srgbClr val="424242"/>
-          </a:solidFill>
-          <a:ln/>
-        </p:spPr>
-      </p:sp>
-      <p:sp>
-        <p:nvSpPr>
-          <p:cNvPr id="3" name="Shape 1"/>
-          <p:cNvSpPr/>
-          <p:nvPr/>
-        </p:nvSpPr>
-        <p:spPr>
-          <a:xfrm>
-            <a:off x="3352800" y="1304925"/>
-            <a:ext cx="2438400" cy="3228975"/>
-          </a:xfrm>
-          <a:prstGeom prst="roundRect">
-            <a:avLst>
-              <a:gd name="adj" fmla="val 6000"/>
-            </a:avLst>
-          </a:prstGeom>
-          <a:solidFill>
-            <a:srgbClr val="424242"/>
-          </a:solidFill>
-          <a:ln/>
-        </p:spPr>
-      </p:sp>
-      <p:sp>
-        <p:nvSpPr>
-          <p:cNvPr id="4" name="Shape 2"/>
-          <p:cNvSpPr/>
-          <p:nvPr/>
-        </p:nvSpPr>
-        <p:spPr>
-          <a:xfrm>
-            <a:off x="6096000" y="1304925"/>
-            <a:ext cx="2438400" cy="3228975"/>
-          </a:xfrm>
-          <a:prstGeom prst="roundRect">
-            <a:avLst>
-              <a:gd name="adj" fmla="val 6000"/>
-            </a:avLst>
-          </a:prstGeom>
-          <a:solidFill>
-            <a:srgbClr val="424242"/>
-          </a:solidFill>
-          <a:ln/>
-        </p:spPr>
-      </p:sp>
-      <p:sp>
-        <p:nvSpPr>
-          <p:cNvPr id="5" name="Text 3"/>
-          <p:cNvSpPr/>
-          <p:nvPr/>
-        </p:nvSpPr>
-        <p:spPr>
-          <a:xfrm>
-            <a:off x="609600" y="609600"/>
-            <a:ext cx="8001000" cy="276225"/>
-          </a:xfrm>
-          <a:prstGeom prst="rect">
-            <a:avLst/>
-          </a:prstGeom>
-          <a:noFill/>
-          <a:ln/>
-        </p:spPr>
-        <p:txBody>
-          <a:bodyPr wrap="square" rtlCol="0" anchor="ctr"/>
-          <a:lstStyle/>
-          <a:p>
-            <a:pPr algn="l" indent="0" marL="0">
-              <a:lnSpc>
-                <a:spcPts val="2160"/>
-              </a:lnSpc>
-              <a:buNone/>
-            </a:pPr>
-            <a:r>
-              <a:rPr lang="en-US" sz="1800" b="1" spc="-36" kern="0" dirty="0">
-                <a:solidFill>
-                  <a:srgbClr val="FFFFFF">
-                    <a:alpha val="99000"/>
-                  </a:srgbClr>
-                </a:solidFill>
-                <a:latin typeface="Inter" pitchFamily="34" charset="0"/>
-                <a:ea typeface="Inter" pitchFamily="34" charset="-122"/>
-                <a:cs typeface="Inter" pitchFamily="34" charset="-120"/>
-              </a:rPr>
-              <a:t>Lecture structure</a:t>
-            </a:r>
-            <a:endParaRPr lang="en-US" sz="1800" dirty="0"/>
-          </a:p>
-        </p:txBody>
-      </p:sp>
-      <p:sp>
-        <p:nvSpPr>
-          <p:cNvPr id="6" name="Text 4"/>
-          <p:cNvSpPr/>
-          <p:nvPr/>
-        </p:nvSpPr>
-        <p:spPr>
-          <a:xfrm>
-            <a:off x="6324600" y="1595438"/>
-            <a:ext cx="2465387" cy="228600"/>
-          </a:xfrm>
-          <a:prstGeom prst="rect">
-            <a:avLst/>
-          </a:prstGeom>
-          <a:noFill/>
-          <a:ln/>
-        </p:spPr>
-        <p:txBody>
-          <a:bodyPr wrap="square" rtlCol="0" anchor="ctr"/>
-          <a:lstStyle/>
-          <a:p>
-            <a:pPr algn="l" indent="0" marL="0">
-              <a:lnSpc>
-                <a:spcPts val="1782"/>
-              </a:lnSpc>
-              <a:buNone/>
-            </a:pPr>
-            <a:r>
-              <a:rPr lang="en-US" sz="1350" spc="-27" kern="0" dirty="0">
-                <a:solidFill>
-                  <a:srgbClr val="FFFFFF">
-                    <a:alpha val="99000"/>
-                  </a:srgbClr>
-                </a:solidFill>
-                <a:latin typeface="Inter" pitchFamily="34" charset="0"/>
-                <a:ea typeface="Inter" pitchFamily="34" charset="-122"/>
-                <a:cs typeface="Inter" pitchFamily="34" charset="-120"/>
-              </a:rPr>
-              <a:t>~40m </a:t>
-            </a:r>
-            <a:endParaRPr lang="en-US" sz="1350" dirty="0"/>
-          </a:p>
-        </p:txBody>
-      </p:sp>
-      <p:sp>
-        <p:nvSpPr>
-          <p:cNvPr id="7" name="Text 5"/>
-          <p:cNvSpPr/>
-          <p:nvPr/>
-        </p:nvSpPr>
-        <p:spPr>
-          <a:xfrm>
-            <a:off x="6324600" y="3667125"/>
-            <a:ext cx="2465387" cy="228600"/>
-          </a:xfrm>
-          <a:prstGeom prst="rect">
-            <a:avLst/>
-          </a:prstGeom>
-          <a:noFill/>
-          <a:ln/>
-        </p:spPr>
-        <p:txBody>
-          <a:bodyPr wrap="square" rtlCol="0" anchor="ctr"/>
-          <a:lstStyle/>
-          <a:p>
-            <a:pPr algn="l" indent="0" marL="0">
-              <a:lnSpc>
-                <a:spcPts val="1782"/>
-              </a:lnSpc>
-              <a:buNone/>
-            </a:pPr>
-            <a:r>
-              <a:rPr lang="en-US" sz="1350" spc="-27" kern="0" dirty="0">
-                <a:solidFill>
-                  <a:srgbClr val="FFFFFF">
-                    <a:alpha val="99000"/>
-                  </a:srgbClr>
-                </a:solidFill>
-                <a:latin typeface="Inter" pitchFamily="34" charset="0"/>
-                <a:ea typeface="Inter" pitchFamily="34" charset="-122"/>
-                <a:cs typeface="Inter" pitchFamily="34" charset="-120"/>
-              </a:rPr>
-              <a:t>You:</a:t>
-            </a:r>
-            <a:endParaRPr lang="en-US" sz="1350" dirty="0"/>
-          </a:p>
-        </p:txBody>
-      </p:sp>
-      <p:sp>
-        <p:nvSpPr>
-          <p:cNvPr id="8" name="Text 6"/>
-          <p:cNvSpPr/>
-          <p:nvPr/>
-        </p:nvSpPr>
-        <p:spPr>
-          <a:xfrm>
-            <a:off x="6324600" y="1824038"/>
-            <a:ext cx="2465387" cy="276225"/>
-          </a:xfrm>
-          <a:prstGeom prst="rect">
-            <a:avLst/>
-          </a:prstGeom>
-          <a:noFill/>
-          <a:ln/>
-        </p:spPr>
-        <p:txBody>
-          <a:bodyPr wrap="square" rtlCol="0" anchor="ctr"/>
-          <a:lstStyle/>
-          <a:p>
-            <a:pPr algn="l" indent="0" marL="0">
-              <a:lnSpc>
-                <a:spcPts val="2160"/>
-              </a:lnSpc>
-              <a:buNone/>
-            </a:pPr>
-            <a:r>
-              <a:rPr lang="en-US" sz="1800" b="1" spc="-36" kern="0" dirty="0">
-                <a:solidFill>
-                  <a:srgbClr val="FFFFFF">
-                    <a:alpha val="99000"/>
-                  </a:srgbClr>
-                </a:solidFill>
-                <a:latin typeface="Inter" pitchFamily="34" charset="0"/>
-                <a:ea typeface="Inter" pitchFamily="34" charset="-122"/>
-                <a:cs typeface="Inter" pitchFamily="34" charset="-120"/>
-              </a:rPr>
-              <a:t>Hands-On</a:t>
-            </a:r>
-            <a:endParaRPr lang="en-US" sz="1800" dirty="0"/>
-          </a:p>
-        </p:txBody>
-      </p:sp>
-      <p:sp>
-        <p:nvSpPr>
-          <p:cNvPr id="9" name="Text 7"/>
-          <p:cNvSpPr/>
-          <p:nvPr/>
-        </p:nvSpPr>
-        <p:spPr>
-          <a:xfrm>
-            <a:off x="6324600" y="3895725"/>
-            <a:ext cx="2465387" cy="276225"/>
-          </a:xfrm>
-          <a:prstGeom prst="rect">
-            <a:avLst/>
-          </a:prstGeom>
-          <a:noFill/>
-          <a:ln/>
-        </p:spPr>
-        <p:txBody>
-          <a:bodyPr wrap="square" rtlCol="0" anchor="ctr"/>
-          <a:lstStyle/>
-          <a:p>
-            <a:pPr algn="l" indent="0" marL="0">
-              <a:lnSpc>
-                <a:spcPts val="2160"/>
-              </a:lnSpc>
-              <a:buNone/>
-            </a:pPr>
-            <a:r>
-              <a:rPr lang="en-US" sz="1800" b="1" spc="-36" kern="0" dirty="0">
-                <a:solidFill>
-                  <a:srgbClr val="FFFFFF">
-                    <a:alpha val="99000"/>
-                  </a:srgbClr>
-                </a:solidFill>
-                <a:latin typeface="Inter" pitchFamily="34" charset="0"/>
-                <a:ea typeface="Inter" pitchFamily="34" charset="-122"/>
-                <a:cs typeface="Inter" pitchFamily="34" charset="-120"/>
-              </a:rPr>
-              <a:t>Practice! </a:t>
-            </a:r>
-            <a:endParaRPr lang="en-US" sz="1800" dirty="0"/>
-          </a:p>
-        </p:txBody>
-      </p:sp>
-      <p:sp>
-        <p:nvSpPr>
-          <p:cNvPr id="10" name="Text 8"/>
-          <p:cNvSpPr/>
-          <p:nvPr/>
-        </p:nvSpPr>
-        <p:spPr>
-          <a:xfrm>
-            <a:off x="3581400" y="1595438"/>
-            <a:ext cx="2465387" cy="228600"/>
-          </a:xfrm>
-          <a:prstGeom prst="rect">
-            <a:avLst/>
-          </a:prstGeom>
-          <a:noFill/>
-          <a:ln/>
-        </p:spPr>
-        <p:txBody>
-          <a:bodyPr wrap="square" rtlCol="0" anchor="ctr"/>
-          <a:lstStyle/>
-          <a:p>
-            <a:pPr algn="l" indent="0" marL="0">
-              <a:lnSpc>
-                <a:spcPts val="1782"/>
-              </a:lnSpc>
-              <a:buNone/>
-            </a:pPr>
-            <a:r>
-              <a:rPr lang="en-US" sz="1350" spc="-27" kern="0" dirty="0">
-                <a:solidFill>
-                  <a:srgbClr val="FFFFFF">
-                    <a:alpha val="99000"/>
-                  </a:srgbClr>
-                </a:solidFill>
-                <a:latin typeface="Inter" pitchFamily="34" charset="0"/>
-                <a:ea typeface="Inter" pitchFamily="34" charset="-122"/>
-                <a:cs typeface="Inter" pitchFamily="34" charset="-120"/>
-              </a:rPr>
-              <a:t>~20m </a:t>
-            </a:r>
-            <a:endParaRPr lang="en-US" sz="1350" dirty="0"/>
-          </a:p>
-        </p:txBody>
-      </p:sp>
-      <p:sp>
-        <p:nvSpPr>
-          <p:cNvPr id="11" name="Text 9"/>
-          <p:cNvSpPr/>
-          <p:nvPr/>
-        </p:nvSpPr>
-        <p:spPr>
-          <a:xfrm>
-            <a:off x="3581400" y="3667125"/>
-            <a:ext cx="2465387" cy="228600"/>
-          </a:xfrm>
-          <a:prstGeom prst="rect">
-            <a:avLst/>
-          </a:prstGeom>
-          <a:noFill/>
-          <a:ln/>
-        </p:spPr>
-        <p:txBody>
-          <a:bodyPr wrap="square" rtlCol="0" anchor="ctr"/>
-          <a:lstStyle/>
-          <a:p>
-            <a:pPr algn="l" indent="0" marL="0">
-              <a:lnSpc>
-                <a:spcPts val="1782"/>
-              </a:lnSpc>
-              <a:buNone/>
-            </a:pPr>
-            <a:r>
-              <a:rPr lang="en-US" sz="1350" spc="-27" kern="0" dirty="0">
-                <a:solidFill>
-                  <a:srgbClr val="FFFFFF">
-                    <a:alpha val="99000"/>
-                  </a:srgbClr>
-                </a:solidFill>
-                <a:latin typeface="Inter" pitchFamily="34" charset="0"/>
-                <a:ea typeface="Inter" pitchFamily="34" charset="-122"/>
-                <a:cs typeface="Inter" pitchFamily="34" charset="-120"/>
-              </a:rPr>
-              <a:t>You:</a:t>
-            </a:r>
-            <a:endParaRPr lang="en-US" sz="1350" dirty="0"/>
-          </a:p>
-        </p:txBody>
-      </p:sp>
-      <p:sp>
-        <p:nvSpPr>
-          <p:cNvPr id="12" name="Text 10"/>
-          <p:cNvSpPr/>
-          <p:nvPr/>
-        </p:nvSpPr>
-        <p:spPr>
-          <a:xfrm>
-            <a:off x="3581400" y="1824038"/>
-            <a:ext cx="2465387" cy="276225"/>
-          </a:xfrm>
-          <a:prstGeom prst="rect">
-            <a:avLst/>
-          </a:prstGeom>
-          <a:noFill/>
-          <a:ln/>
-        </p:spPr>
-        <p:txBody>
-          <a:bodyPr wrap="square" rtlCol="0" anchor="ctr"/>
-          <a:lstStyle/>
-          <a:p>
-            <a:pPr algn="l" indent="0" marL="0">
-              <a:lnSpc>
-                <a:spcPts val="2160"/>
-              </a:lnSpc>
-              <a:buNone/>
-            </a:pPr>
-            <a:r>
-              <a:rPr lang="en-US" sz="1800" b="1" spc="-36" kern="0" dirty="0">
-                <a:solidFill>
-                  <a:srgbClr val="FFFFFF">
-                    <a:alpha val="99000"/>
-                  </a:srgbClr>
-                </a:solidFill>
-                <a:latin typeface="Inter" pitchFamily="34" charset="0"/>
-                <a:ea typeface="Inter" pitchFamily="34" charset="-122"/>
-                <a:cs typeface="Inter" pitchFamily="34" charset="-120"/>
-              </a:rPr>
-              <a:t>Demo</a:t>
-            </a:r>
-            <a:endParaRPr lang="en-US" sz="1800" dirty="0"/>
-          </a:p>
-        </p:txBody>
-      </p:sp>
-      <p:sp>
-        <p:nvSpPr>
-          <p:cNvPr id="13" name="Text 11"/>
-          <p:cNvSpPr/>
-          <p:nvPr/>
-        </p:nvSpPr>
-        <p:spPr>
-          <a:xfrm>
-            <a:off x="3581400" y="3895725"/>
-            <a:ext cx="2465387" cy="276225"/>
-          </a:xfrm>
-          <a:prstGeom prst="rect">
-            <a:avLst/>
-          </a:prstGeom>
-          <a:noFill/>
-          <a:ln/>
-        </p:spPr>
-        <p:txBody>
-          <a:bodyPr wrap="square" rtlCol="0" anchor="ctr"/>
-          <a:lstStyle/>
-          <a:p>
-            <a:pPr algn="l" indent="0" marL="0">
-              <a:lnSpc>
-                <a:spcPts val="2160"/>
-              </a:lnSpc>
-              <a:buNone/>
-            </a:pPr>
-            <a:r>
-              <a:rPr lang="en-US" sz="1800" b="1" spc="-36" kern="0" dirty="0">
-                <a:solidFill>
-                  <a:srgbClr val="FFFFFF">
-                    <a:alpha val="99000"/>
-                  </a:srgbClr>
-                </a:solidFill>
-                <a:latin typeface="Inter" pitchFamily="34" charset="0"/>
-                <a:ea typeface="Inter" pitchFamily="34" charset="-122"/>
-                <a:cs typeface="Inter" pitchFamily="34" charset="-120"/>
-              </a:rPr>
-              <a:t>Follow along</a:t>
-            </a:r>
-            <a:endParaRPr lang="en-US" sz="1800" dirty="0"/>
-          </a:p>
-        </p:txBody>
-      </p:sp>
-      <p:sp>
-        <p:nvSpPr>
-          <p:cNvPr id="14" name="Text 12"/>
-          <p:cNvSpPr/>
-          <p:nvPr/>
-        </p:nvSpPr>
-        <p:spPr>
-          <a:xfrm>
-            <a:off x="838200" y="1600200"/>
-            <a:ext cx="2465387" cy="228600"/>
-          </a:xfrm>
-          <a:prstGeom prst="rect">
-            <a:avLst/>
-          </a:prstGeom>
-          <a:noFill/>
-          <a:ln/>
-        </p:spPr>
-        <p:txBody>
-          <a:bodyPr wrap="square" rtlCol="0" anchor="ctr"/>
-          <a:lstStyle/>
-          <a:p>
-            <a:pPr algn="l" indent="0" marL="0">
-              <a:lnSpc>
-                <a:spcPts val="1782"/>
-              </a:lnSpc>
-              <a:buNone/>
-            </a:pPr>
-            <a:r>
-              <a:rPr lang="en-US" sz="1350" spc="-27" kern="0" dirty="0">
-                <a:solidFill>
-                  <a:srgbClr val="FFFFFF">
-                    <a:alpha val="99000"/>
-                  </a:srgbClr>
-                </a:solidFill>
-                <a:latin typeface="Inter" pitchFamily="34" charset="0"/>
-                <a:ea typeface="Inter" pitchFamily="34" charset="-122"/>
-                <a:cs typeface="Inter" pitchFamily="34" charset="-120"/>
-              </a:rPr>
-              <a:t>~15m </a:t>
-            </a:r>
-            <a:endParaRPr lang="en-US" sz="1350" dirty="0"/>
-          </a:p>
-        </p:txBody>
-      </p:sp>
-      <p:sp>
-        <p:nvSpPr>
-          <p:cNvPr id="15" name="Text 13"/>
-          <p:cNvSpPr/>
-          <p:nvPr/>
-        </p:nvSpPr>
-        <p:spPr>
-          <a:xfrm>
-            <a:off x="838200" y="3671888"/>
-            <a:ext cx="2465387" cy="228600"/>
-          </a:xfrm>
-          <a:prstGeom prst="rect">
-            <a:avLst/>
-          </a:prstGeom>
-          <a:noFill/>
-          <a:ln/>
-        </p:spPr>
-        <p:txBody>
-          <a:bodyPr wrap="square" rtlCol="0" anchor="ctr"/>
-          <a:lstStyle/>
-          <a:p>
-            <a:pPr algn="l" indent="0" marL="0">
-              <a:lnSpc>
-                <a:spcPts val="1782"/>
-              </a:lnSpc>
-              <a:buNone/>
-            </a:pPr>
-            <a:r>
-              <a:rPr lang="en-US" sz="1350" spc="-27" kern="0" dirty="0">
-                <a:solidFill>
-                  <a:srgbClr val="FFFFFF">
-                    <a:alpha val="99000"/>
-                  </a:srgbClr>
-                </a:solidFill>
-                <a:latin typeface="Inter" pitchFamily="34" charset="0"/>
-                <a:ea typeface="Inter" pitchFamily="34" charset="-122"/>
-                <a:cs typeface="Inter" pitchFamily="34" charset="-120"/>
-              </a:rPr>
-              <a:t>You:</a:t>
-            </a:r>
-            <a:endParaRPr lang="en-US" sz="1350" dirty="0"/>
-          </a:p>
-        </p:txBody>
-      </p:sp>
-      <p:sp>
-        <p:nvSpPr>
-          <p:cNvPr id="16" name="Text 14"/>
-          <p:cNvSpPr/>
-          <p:nvPr/>
-        </p:nvSpPr>
-        <p:spPr>
-          <a:xfrm>
-            <a:off x="838200" y="1828800"/>
-            <a:ext cx="2465387" cy="276225"/>
-          </a:xfrm>
-          <a:prstGeom prst="rect">
-            <a:avLst/>
-          </a:prstGeom>
-          <a:noFill/>
-          <a:ln/>
-        </p:spPr>
-        <p:txBody>
-          <a:bodyPr wrap="square" rtlCol="0" anchor="ctr"/>
-          <a:lstStyle/>
-          <a:p>
-            <a:pPr algn="l" indent="0" marL="0">
-              <a:lnSpc>
-                <a:spcPts val="2160"/>
-              </a:lnSpc>
-              <a:buNone/>
-            </a:pPr>
-            <a:r>
-              <a:rPr lang="en-US" sz="1800" b="1" spc="-36" kern="0" dirty="0">
-                <a:solidFill>
-                  <a:srgbClr val="FFFFFF">
-                    <a:alpha val="99000"/>
-                  </a:srgbClr>
-                </a:solidFill>
-                <a:latin typeface="Inter" pitchFamily="34" charset="0"/>
-                <a:ea typeface="Inter" pitchFamily="34" charset="-122"/>
-                <a:cs typeface="Inter" pitchFamily="34" charset="-120"/>
-              </a:rPr>
-              <a:t>Lecture</a:t>
-            </a:r>
-            <a:endParaRPr lang="en-US" sz="1800" dirty="0"/>
-          </a:p>
-        </p:txBody>
-      </p:sp>
-      <p:sp>
-        <p:nvSpPr>
-          <p:cNvPr id="17" name="Text 15"/>
-          <p:cNvSpPr/>
-          <p:nvPr/>
-        </p:nvSpPr>
-        <p:spPr>
-          <a:xfrm>
-            <a:off x="838200" y="3900488"/>
-            <a:ext cx="2465387" cy="276225"/>
-          </a:xfrm>
-          <a:prstGeom prst="rect">
-            <a:avLst/>
-          </a:prstGeom>
-          <a:noFill/>
-          <a:ln/>
-        </p:spPr>
-        <p:txBody>
-          <a:bodyPr wrap="square" rtlCol="0" anchor="ctr"/>
-          <a:lstStyle/>
-          <a:p>
-            <a:pPr algn="l" indent="0" marL="0">
-              <a:lnSpc>
-                <a:spcPts val="2160"/>
-              </a:lnSpc>
-              <a:buNone/>
-            </a:pPr>
-            <a:r>
-              <a:rPr lang="en-US" sz="1800" b="1" spc="-36" kern="0" dirty="0">
-                <a:solidFill>
-                  <a:srgbClr val="FFFFFF">
-                    <a:alpha val="99000"/>
-                  </a:srgbClr>
-                </a:solidFill>
-                <a:latin typeface="Inter" pitchFamily="34" charset="0"/>
-                <a:ea typeface="Inter" pitchFamily="34" charset="-122"/>
-                <a:cs typeface="Inter" pitchFamily="34" charset="-120"/>
-              </a:rPr>
-              <a:t>Listen and discuss</a:t>
-            </a:r>
-            <a:endParaRPr lang="en-US" sz="1800" dirty="0"/>
-          </a:p>
-        </p:txBody>
-      </p:sp>
-    </p:spTree>
-  </p:cSld>
-  <p:clrMapOvr>
-    <a:masterClrMapping/>
-  </p:clrMapOvr>
-</p:sld>
-</file>
-
-<file path=ppt/slides/slide8.xml><?xml version="1.0" encoding="utf-8"?>
-<p:sld xmlns:a="http://schemas.openxmlformats.org/drawingml/2006/main" xmlns:r="http://schemas.openxmlformats.org/officeDocument/2006/relationships" xmlns:p="http://schemas.openxmlformats.org/presentationml/2006/main">
-  <p:cSld name="Slide 8">
-    <p:bg>
-      <p:bgPr>
-        <a:solidFill>
-          <a:srgbClr val="000000"/>
-        </a:solidFill>
-      </p:bgPr>
-    </p:bg>
-    <p:spTree>
-      <p:nvGrpSpPr>
-        <p:cNvPr id="1" name=""/>
-        <p:cNvGrpSpPr/>
-        <p:nvPr/>
-      </p:nvGrpSpPr>
-      <p:grpSpPr>
-        <a:xfrm>
-          <a:off x="0" y="0"/>
-          <a:ext cx="0" cy="0"/>
-          <a:chOff x="0" y="0"/>
-          <a:chExt cx="0" cy="0"/>
-        </a:xfrm>
-      </p:grpSpPr>
-      <p:sp>
-        <p:nvSpPr>
-          <p:cNvPr id="2" name="Shape 0"/>
-          <p:cNvSpPr/>
-          <p:nvPr/>
-        </p:nvSpPr>
-        <p:spPr>
-          <a:xfrm>
             <a:off x="1714500" y="2124075"/>
             <a:ext cx="5715000" cy="900113"/>
           </a:xfrm>
@@ -3354,6 +2774,13 @@
           <a:noFill/>
           <a:ln/>
         </p:spPr>
+        <p:txBody>
+          <a:bodyPr/>
+          <a:lstStyle/>
+          <a:p>
+            <a:endParaRPr lang="en-US"/>
+          </a:p>
+        </p:txBody>
       </p:sp>
       <p:sp>
         <p:nvSpPr>
@@ -3376,14 +2803,14 @@
           <a:bodyPr wrap="square" rtlCol="0" anchor="ctr"/>
           <a:lstStyle/>
           <a:p>
-            <a:pPr algn="ctr" indent="0" marL="0">
+            <a:pPr marL="0" indent="0" algn="ctr">
               <a:lnSpc>
                 <a:spcPts val="4320"/>
               </a:lnSpc>
               <a:buNone/>
             </a:pPr>
             <a:r>
-              <a:rPr lang="en-US" sz="3600" b="1" spc="-72" kern="0" dirty="0">
+              <a:rPr lang="en-US" sz="3600" b="1" kern="0" spc="-72" dirty="0">
                 <a:solidFill>
                   <a:srgbClr val="FFFFFF">
                     <a:alpha val="99000"/>
@@ -3420,14 +2847,14 @@
           <a:bodyPr wrap="square" rtlCol="0" anchor="ctr"/>
           <a:lstStyle/>
           <a:p>
-            <a:pPr algn="ctr" indent="0" marL="0">
+            <a:pPr marL="0" indent="0" algn="ctr">
               <a:lnSpc>
                 <a:spcPts val="1890"/>
               </a:lnSpc>
               <a:buNone/>
             </a:pPr>
             <a:r>
-              <a:rPr lang="en-US" sz="1350" spc="-13" kern="0" dirty="0">
+              <a:rPr lang="en-US" sz="1350" kern="0" spc="-13" dirty="0">
                 <a:solidFill>
                   <a:srgbClr val="FFFFFF">
                     <a:alpha val="99000"/>
@@ -3437,7 +2864,7 @@
                 <a:ea typeface="Inter" pitchFamily="34" charset="-122"/>
                 <a:cs typeface="Inter" pitchFamily="34" charset="-120"/>
               </a:rPr>
-              <a:t>Ask questions through (https://discord.gg/T8zN36C6)</a:t>
+              <a:t>Ask questions through MS Teams</a:t>
             </a:r>
             <a:endParaRPr lang="en-US" sz="1350" dirty="0"/>
           </a:p>
@@ -3744,4 +3171,319 @@
     </a:ext>
   </a:extLst>
 </a:theme>
+</file>
+
+<file path=ppt/theme/theme2.xml><?xml version="1.0" encoding="utf-8"?>
+<a:theme xmlns:a="http://schemas.openxmlformats.org/drawingml/2006/main" name="Office Theme">
+  <a:themeElements>
+    <a:clrScheme name="Office">
+      <a:dk1>
+        <a:sysClr val="windowText" lastClr="000000"/>
+      </a:dk1>
+      <a:lt1>
+        <a:sysClr val="window" lastClr="FFFFFF"/>
+      </a:lt1>
+      <a:dk2>
+        <a:srgbClr val="0E2841"/>
+      </a:dk2>
+      <a:lt2>
+        <a:srgbClr val="E8E8E8"/>
+      </a:lt2>
+      <a:accent1>
+        <a:srgbClr val="156082"/>
+      </a:accent1>
+      <a:accent2>
+        <a:srgbClr val="E97132"/>
+      </a:accent2>
+      <a:accent3>
+        <a:srgbClr val="196B24"/>
+      </a:accent3>
+      <a:accent4>
+        <a:srgbClr val="0F9ED5"/>
+      </a:accent4>
+      <a:accent5>
+        <a:srgbClr val="A02B93"/>
+      </a:accent5>
+      <a:accent6>
+        <a:srgbClr val="4EA72E"/>
+      </a:accent6>
+      <a:hlink>
+        <a:srgbClr val="467886"/>
+      </a:hlink>
+      <a:folHlink>
+        <a:srgbClr val="96607D"/>
+      </a:folHlink>
+    </a:clrScheme>
+    <a:fontScheme name="Office">
+      <a:majorFont>
+        <a:latin typeface="Aptos Display" panose="02110004020202020204"/>
+        <a:ea typeface=""/>
+        <a:cs typeface=""/>
+        <a:font script="Jpan" typeface="游ゴシック Light"/>
+        <a:font script="Hang" typeface="맑은 고딕"/>
+        <a:font script="Hans" typeface="等线 Light"/>
+        <a:font script="Hant" typeface="新細明體"/>
+        <a:font script="Arab" typeface="Times New Roman"/>
+        <a:font script="Hebr" typeface="Times New Roman"/>
+        <a:font script="Thai" typeface="Angsana New"/>
+        <a:font script="Ethi" typeface="Nyala"/>
+        <a:font script="Beng" typeface="Vrinda"/>
+        <a:font script="Gujr" typeface="Shruti"/>
+        <a:font script="Khmr" typeface="MoolBoran"/>
+        <a:font script="Knda" typeface="Tunga"/>
+        <a:font script="Guru" typeface="Raavi"/>
+        <a:font script="Cans" typeface="Euphemia"/>
+        <a:font script="Cher" typeface="Plantagenet Cherokee"/>
+        <a:font script="Yiii" typeface="Microsoft Yi Baiti"/>
+        <a:font script="Tibt" typeface="Microsoft Himalaya"/>
+        <a:font script="Thaa" typeface="MV Boli"/>
+        <a:font script="Deva" typeface="Mangal"/>
+        <a:font script="Telu" typeface="Gautami"/>
+        <a:font script="Taml" typeface="Latha"/>
+        <a:font script="Syrc" typeface="Estrangelo Edessa"/>
+        <a:font script="Orya" typeface="Kalinga"/>
+        <a:font script="Mlym" typeface="Kartika"/>
+        <a:font script="Laoo" typeface="DokChampa"/>
+        <a:font script="Sinh" typeface="Iskoola Pota"/>
+        <a:font script="Mong" typeface="Mongolian Baiti"/>
+        <a:font script="Viet" typeface="Times New Roman"/>
+        <a:font script="Uigh" typeface="Microsoft Uighur"/>
+        <a:font script="Geor" typeface="Sylfaen"/>
+        <a:font script="Armn" typeface="Arial"/>
+        <a:font script="Bugi" typeface="Leelawadee UI"/>
+        <a:font script="Bopo" typeface="Microsoft JhengHei"/>
+        <a:font script="Java" typeface="Javanese Text"/>
+        <a:font script="Lisu" typeface="Segoe UI"/>
+        <a:font script="Mymr" typeface="Myanmar Text"/>
+        <a:font script="Nkoo" typeface="Ebrima"/>
+        <a:font script="Olck" typeface="Nirmala UI"/>
+        <a:font script="Osma" typeface="Ebrima"/>
+        <a:font script="Phag" typeface="Phagspa"/>
+        <a:font script="Syrn" typeface="Estrangelo Edessa"/>
+        <a:font script="Syrj" typeface="Estrangelo Edessa"/>
+        <a:font script="Syre" typeface="Estrangelo Edessa"/>
+        <a:font script="Sora" typeface="Nirmala UI"/>
+        <a:font script="Tale" typeface="Microsoft Tai Le"/>
+        <a:font script="Talu" typeface="Microsoft New Tai Lue"/>
+        <a:font script="Tfng" typeface="Ebrima"/>
+      </a:majorFont>
+      <a:minorFont>
+        <a:latin typeface="Aptos" panose="02110004020202020204"/>
+        <a:ea typeface=""/>
+        <a:cs typeface=""/>
+        <a:font script="Jpan" typeface="游ゴシック"/>
+        <a:font script="Hang" typeface="맑은 고딕"/>
+        <a:font script="Hans" typeface="等线"/>
+        <a:font script="Hant" typeface="新細明體"/>
+        <a:font script="Arab" typeface="Arial"/>
+        <a:font script="Hebr" typeface="Arial"/>
+        <a:font script="Thai" typeface="Cordia New"/>
+        <a:font script="Ethi" typeface="Nyala"/>
+        <a:font script="Beng" typeface="Vrinda"/>
+        <a:font script="Gujr" typeface="Shruti"/>
+        <a:font script="Khmr" typeface="DaunPenh"/>
+        <a:font script="Knda" typeface="Tunga"/>
+        <a:font script="Guru" typeface="Raavi"/>
+        <a:font script="Cans" typeface="Euphemia"/>
+        <a:font script="Cher" typeface="Plantagenet Cherokee"/>
+        <a:font script="Yiii" typeface="Microsoft Yi Baiti"/>
+        <a:font script="Tibt" typeface="Microsoft Himalaya"/>
+        <a:font script="Thaa" typeface="MV Boli"/>
+        <a:font script="Deva" typeface="Mangal"/>
+        <a:font script="Telu" typeface="Gautami"/>
+        <a:font script="Taml" typeface="Latha"/>
+        <a:font script="Syrc" typeface="Estrangelo Edessa"/>
+        <a:font script="Orya" typeface="Kalinga"/>
+        <a:font script="Mlym" typeface="Kartika"/>
+        <a:font script="Laoo" typeface="DokChampa"/>
+        <a:font script="Sinh" typeface="Iskoola Pota"/>
+        <a:font script="Mong" typeface="Mongolian Baiti"/>
+        <a:font script="Viet" typeface="Arial"/>
+        <a:font script="Uigh" typeface="Microsoft Uighur"/>
+        <a:font script="Geor" typeface="Sylfaen"/>
+        <a:font script="Armn" typeface="Arial"/>
+        <a:font script="Bugi" typeface="Leelawadee UI"/>
+        <a:font script="Bopo" typeface="Microsoft JhengHei"/>
+        <a:font script="Java" typeface="Javanese Text"/>
+        <a:font script="Lisu" typeface="Segoe UI"/>
+        <a:font script="Mymr" typeface="Myanmar Text"/>
+        <a:font script="Nkoo" typeface="Ebrima"/>
+        <a:font script="Olck" typeface="Nirmala UI"/>
+        <a:font script="Osma" typeface="Ebrima"/>
+        <a:font script="Phag" typeface="Phagspa"/>
+        <a:font script="Syrn" typeface="Estrangelo Edessa"/>
+        <a:font script="Syrj" typeface="Estrangelo Edessa"/>
+        <a:font script="Syre" typeface="Estrangelo Edessa"/>
+        <a:font script="Sora" typeface="Nirmala UI"/>
+        <a:font script="Tale" typeface="Microsoft Tai Le"/>
+        <a:font script="Talu" typeface="Microsoft New Tai Lue"/>
+        <a:font script="Tfng" typeface="Ebrima"/>
+      </a:minorFont>
+    </a:fontScheme>
+    <a:fmtScheme name="Office">
+      <a:fillStyleLst>
+        <a:solidFill>
+          <a:schemeClr val="phClr"/>
+        </a:solidFill>
+        <a:gradFill rotWithShape="1">
+          <a:gsLst>
+            <a:gs pos="0">
+              <a:schemeClr val="phClr">
+                <a:lumMod val="110000"/>
+                <a:satMod val="105000"/>
+                <a:tint val="67000"/>
+              </a:schemeClr>
+            </a:gs>
+            <a:gs pos="50000">
+              <a:schemeClr val="phClr">
+                <a:lumMod val="105000"/>
+                <a:satMod val="103000"/>
+                <a:tint val="73000"/>
+              </a:schemeClr>
+            </a:gs>
+            <a:gs pos="100000">
+              <a:schemeClr val="phClr">
+                <a:lumMod val="105000"/>
+                <a:satMod val="109000"/>
+                <a:tint val="81000"/>
+              </a:schemeClr>
+            </a:gs>
+          </a:gsLst>
+          <a:lin ang="5400000" scaled="0"/>
+        </a:gradFill>
+        <a:gradFill rotWithShape="1">
+          <a:gsLst>
+            <a:gs pos="0">
+              <a:schemeClr val="phClr">
+                <a:satMod val="103000"/>
+                <a:lumMod val="102000"/>
+                <a:tint val="94000"/>
+              </a:schemeClr>
+            </a:gs>
+            <a:gs pos="50000">
+              <a:schemeClr val="phClr">
+                <a:satMod val="110000"/>
+                <a:lumMod val="100000"/>
+                <a:shade val="100000"/>
+              </a:schemeClr>
+            </a:gs>
+            <a:gs pos="100000">
+              <a:schemeClr val="phClr">
+                <a:lumMod val="99000"/>
+                <a:satMod val="120000"/>
+                <a:shade val="78000"/>
+              </a:schemeClr>
+            </a:gs>
+          </a:gsLst>
+          <a:lin ang="5400000" scaled="0"/>
+        </a:gradFill>
+      </a:fillStyleLst>
+      <a:lnStyleLst>
+        <a:ln w="12700" cap="flat" cmpd="sng" algn="ctr">
+          <a:solidFill>
+            <a:schemeClr val="phClr"/>
+          </a:solidFill>
+          <a:prstDash val="solid"/>
+          <a:miter lim="800000"/>
+        </a:ln>
+        <a:ln w="19050" cap="flat" cmpd="sng" algn="ctr">
+          <a:solidFill>
+            <a:schemeClr val="phClr"/>
+          </a:solidFill>
+          <a:prstDash val="solid"/>
+          <a:miter lim="800000"/>
+        </a:ln>
+        <a:ln w="25400" cap="flat" cmpd="sng" algn="ctr">
+          <a:solidFill>
+            <a:schemeClr val="phClr"/>
+          </a:solidFill>
+          <a:prstDash val="solid"/>
+          <a:miter lim="800000"/>
+        </a:ln>
+      </a:lnStyleLst>
+      <a:effectStyleLst>
+        <a:effectStyle>
+          <a:effectLst/>
+        </a:effectStyle>
+        <a:effectStyle>
+          <a:effectLst/>
+        </a:effectStyle>
+        <a:effectStyle>
+          <a:effectLst>
+            <a:outerShdw blurRad="57150" dist="19050" dir="5400000" algn="ctr" rotWithShape="0">
+              <a:srgbClr val="000000">
+                <a:alpha val="63000"/>
+              </a:srgbClr>
+            </a:outerShdw>
+          </a:effectLst>
+        </a:effectStyle>
+      </a:effectStyleLst>
+      <a:bgFillStyleLst>
+        <a:solidFill>
+          <a:schemeClr val="phClr"/>
+        </a:solidFill>
+        <a:solidFill>
+          <a:schemeClr val="phClr">
+            <a:tint val="95000"/>
+            <a:satMod val="170000"/>
+          </a:schemeClr>
+        </a:solidFill>
+        <a:gradFill rotWithShape="1">
+          <a:gsLst>
+            <a:gs pos="0">
+              <a:schemeClr val="phClr">
+                <a:tint val="93000"/>
+                <a:satMod val="150000"/>
+                <a:shade val="98000"/>
+                <a:lumMod val="102000"/>
+              </a:schemeClr>
+            </a:gs>
+            <a:gs pos="50000">
+              <a:schemeClr val="phClr">
+                <a:tint val="98000"/>
+                <a:satMod val="130000"/>
+                <a:shade val="90000"/>
+                <a:lumMod val="103000"/>
+              </a:schemeClr>
+            </a:gs>
+            <a:gs pos="100000">
+              <a:schemeClr val="phClr">
+                <a:shade val="63000"/>
+                <a:satMod val="120000"/>
+              </a:schemeClr>
+            </a:gs>
+          </a:gsLst>
+          <a:lin ang="5400000" scaled="0"/>
+        </a:gradFill>
+      </a:bgFillStyleLst>
+    </a:fmtScheme>
+  </a:themeElements>
+  <a:objectDefaults>
+    <a:lnDef>
+      <a:spPr/>
+      <a:bodyPr/>
+      <a:lstStyle/>
+      <a:style>
+        <a:lnRef idx="2">
+          <a:schemeClr val="accent1"/>
+        </a:lnRef>
+        <a:fillRef idx="0">
+          <a:schemeClr val="accent1"/>
+        </a:fillRef>
+        <a:effectRef idx="1">
+          <a:schemeClr val="accent1"/>
+        </a:effectRef>
+        <a:fontRef idx="minor">
+          <a:schemeClr val="tx1"/>
+        </a:fontRef>
+      </a:style>
+    </a:lnDef>
+  </a:objectDefaults>
+  <a:extraClrSchemeLst/>
+  <a:extLst>
+    <a:ext uri="{05A4C25C-085E-4340-85A3-A5531E510DB2}">
+      <thm15:themeFamily xmlns:thm15="http://schemas.microsoft.com/office/thememl/2012/main" name="Office Theme" id="{2E142A2C-CD16-42D6-873A-C26D2A0506FA}" vid="{1BDDFF52-6CD6-40A5-AB3C-68EB2F1E4D0A}"/>
+    </a:ext>
+  </a:extLst>
+</a:theme>
 </file>
</xml_diff>